<commit_message>
Link RGB photo evidence and update presentation references
Co-authored-by: Copilot <223556219+Copilot@users.noreply.github.com>
</commit_message>
<xml_diff>
--- a/SENTRY_SWM2_Defense.pptx
+++ b/SENTRY_SWM2_Defense.pptx
@@ -692,6 +692,12 @@
           <a:p>
             <a:r>
               <a:t>Physical observations remain manual. The new assertion-based tests are shown on slide 7. All logs were sanitised.</a:t>
+            </a:r>
+          </a:p>
+          <a:p/>
+          <a:p>
+            <a:r>
+              <a:t>RGB photo evidence: evidence/README.md (red, green and blue original photos; manual visual confirmations).</a:t>
             </a:r>
           </a:p>
         </p:txBody>

</xml_diff>

<commit_message>
Embed RGB evidence photos and add visual charts to defense deck
Co-authored-by: Copilot <223556219+Copilot@users.noreply.github.com>
</commit_message>
<xml_diff>
--- a/SENTRY_SWM2_Defense.pptx
+++ b/SENTRY_SWM2_Defense.pptx
@@ -673,12 +673,18 @@
           <a:lstStyle/>
           <a:p>
             <a:r>
-              <a:t>[Show the bench photo or diagram; if you want, play 15–20 s of the LED video here.]</a:t>
+              <a:t>[Point to the embedded red, green and blue photos. If time permits, play 15–20 s of the separate LED video.]</a:t>
             </a:r>
           </a:p>
           <a:p/>
           <a:p>
             <a:r>
+              <a:t>[Original red, green and blue photos are linked in the evidence index: `evidence/README.md`.]</a:t>
+            </a:r>
+          </a:p>
+          <a:p/>
+          <a:p>
+            <a:r>
               <a:t>This is the bench. An ESP32-S3 board connected over UART at 115200 baud, a Wi-Fi network with a local OTA server, an ultrasonic sonar, a relay module on GPIO8, an RGB lamp on GPIO48, four buttons on GPIO41, 40, 39 and 38, and a proximity LED on GPIO4.</a:t>
             </a:r>
           </a:p>
@@ -692,12 +698,6 @@
           <a:p>
             <a:r>
               <a:t>Physical observations remain manual. The new assertion-based tests are shown on slide 7. All logs were sanitised.</a:t>
-            </a:r>
-          </a:p>
-          <a:p/>
-          <a:p>
-            <a:r>
-              <a:t>RGB photo evidence: evidence/README.md (red, green and blue original photos; manual visual confirmations).</a:t>
             </a:r>
           </a:p>
         </p:txBody>
@@ -4840,390 +4840,1028 @@
       </p:sp>
       <p:sp>
         <p:nvSpPr>
-          <p:cNvPr id="7" name="TextBox 6"/>
-          <p:cNvSpPr txBox="1"/>
-          <p:nvPr/>
-        </p:nvSpPr>
-        <p:spPr>
-          <a:xfrm>
-            <a:off x="594360" y="1828800"/>
-            <a:ext cx="274320" cy="457200"/>
-          </a:xfrm>
-          <a:prstGeom prst="rect">
-            <a:avLst/>
-          </a:prstGeom>
-          <a:noFill/>
-        </p:spPr>
-        <p:txBody>
-          <a:bodyPr wrap="square" lIns="73152" rIns="73152" tIns="36576" bIns="36576">
-            <a:spAutoFit/>
-          </a:bodyPr>
-          <a:lstStyle/>
-          <a:p>
-            <a:pPr>
-              <a:spcAft>
-                <a:spcPts val="1200"/>
-              </a:spcAft>
-            </a:pPr>
-            <a:r>
-              <a:rPr sz="2300" b="1">
+          <p:cNvPr id="7" name="Rounded Rectangle 6"/>
+          <p:cNvSpPr/>
+          <p:nvPr/>
+        </p:nvSpPr>
+        <p:spPr>
+          <a:xfrm>
+            <a:off x="594360" y="1783080"/>
+            <a:ext cx="4023360" cy="3566160"/>
+          </a:xfrm>
+          <a:prstGeom prst="roundRect">
+            <a:avLst/>
+          </a:prstGeom>
+          <a:solidFill>
+            <a:srgbClr val="E8F1F7"/>
+          </a:solidFill>
+          <a:ln>
+            <a:noFill/>
+          </a:ln>
+        </p:spPr>
+        <p:style>
+          <a:lnRef idx="1">
+            <a:schemeClr val="accent1"/>
+          </a:lnRef>
+          <a:fillRef idx="3">
+            <a:schemeClr val="accent1"/>
+          </a:fillRef>
+          <a:effectRef idx="2">
+            <a:schemeClr val="accent1"/>
+          </a:effectRef>
+          <a:fontRef idx="minor">
+            <a:schemeClr val="lt1"/>
+          </a:fontRef>
+        </p:style>
+        <p:txBody>
+          <a:bodyPr rtlCol="0" anchor="ctr"/>
+          <a:lstStyle/>
+          <a:p>
+            <a:pPr algn="ctr"/>
+          </a:p>
+        </p:txBody>
+      </p:sp>
+      <p:sp>
+        <p:nvSpPr>
+          <p:cNvPr id="8" name="TextBox 7"/>
+          <p:cNvSpPr txBox="1"/>
+          <p:nvPr/>
+        </p:nvSpPr>
+        <p:spPr>
+          <a:xfrm>
+            <a:off x="777240" y="1965960"/>
+            <a:ext cx="3657600" cy="594360"/>
+          </a:xfrm>
+          <a:prstGeom prst="rect">
+            <a:avLst/>
+          </a:prstGeom>
+          <a:noFill/>
+        </p:spPr>
+        <p:txBody>
+          <a:bodyPr wrap="square" lIns="73152" rIns="73152" tIns="36576" bIns="36576">
+            <a:spAutoFit/>
+          </a:bodyPr>
+          <a:lstStyle/>
+          <a:p>
+            <a:pPr>
+              <a:spcAft>
+                <a:spcPts val="1200"/>
+              </a:spcAft>
+            </a:pPr>
+            <a:r>
+              <a:rPr sz="2600" b="1">
                 <a:solidFill>
                   <a:srgbClr val="075985"/>
                 </a:solidFill>
                 <a:latin typeface="Arial"/>
               </a:rPr>
-              <a:t>-</a:t>
-            </a:r>
-          </a:p>
-        </p:txBody>
-      </p:sp>
-      <p:sp>
-        <p:nvSpPr>
-          <p:cNvPr id="8" name="TextBox 7"/>
-          <p:cNvSpPr txBox="1"/>
-          <p:nvPr/>
-        </p:nvSpPr>
-        <p:spPr>
-          <a:xfrm>
-            <a:off x="914400" y="1828800"/>
-            <a:ext cx="10607040" cy="704088"/>
-          </a:xfrm>
-          <a:prstGeom prst="rect">
-            <a:avLst/>
-          </a:prstGeom>
-          <a:noFill/>
-        </p:spPr>
-        <p:txBody>
-          <a:bodyPr wrap="square" lIns="73152" rIns="73152" tIns="36576" bIns="36576">
-            <a:spAutoFit/>
-          </a:bodyPr>
-          <a:lstStyle/>
-          <a:p>
-            <a:pPr>
-              <a:spcAft>
-                <a:spcPts val="1200"/>
-              </a:spcAft>
-            </a:pPr>
-            <a:r>
-              <a:rPr sz="2300" b="0">
+              <a:t>67 defined test cases</a:t>
+            </a:r>
+          </a:p>
+        </p:txBody>
+      </p:sp>
+      <p:sp>
+        <p:nvSpPr>
+          <p:cNvPr id="9" name="TextBox 8"/>
+          <p:cNvSpPr txBox="1"/>
+          <p:nvPr/>
+        </p:nvSpPr>
+        <p:spPr>
+          <a:xfrm>
+            <a:off x="777240" y="2743200"/>
+            <a:ext cx="3657600" cy="2286000"/>
+          </a:xfrm>
+          <a:prstGeom prst="rect">
+            <a:avLst/>
+          </a:prstGeom>
+          <a:noFill/>
+        </p:spPr>
+        <p:txBody>
+          <a:bodyPr wrap="square" lIns="73152" rIns="73152" tIns="36576" bIns="36576">
+            <a:spAutoFit/>
+          </a:bodyPr>
+          <a:lstStyle/>
+          <a:p>
+            <a:pPr>
+              <a:spcAft>
+                <a:spcPts val="1200"/>
+              </a:spcAft>
+            </a:pPr>
+            <a:r>
+              <a:rPr sz="2200" b="0">
                 <a:solidFill>
                   <a:srgbClr val="10243A"/>
                 </a:solidFill>
                 <a:latin typeface="Arial"/>
               </a:rPr>
-              <a:t>PRD -&gt; traceability matrix -&gt; 67 defined test cases.</a:t>
-            </a:r>
-          </a:p>
-        </p:txBody>
-      </p:sp>
-      <p:sp>
-        <p:nvSpPr>
-          <p:cNvPr id="9" name="TextBox 8"/>
-          <p:cNvSpPr txBox="1"/>
-          <p:nvPr/>
-        </p:nvSpPr>
-        <p:spPr>
-          <a:xfrm>
-            <a:off x="594360" y="2596896"/>
-            <a:ext cx="274320" cy="457200"/>
-          </a:xfrm>
-          <a:prstGeom prst="rect">
-            <a:avLst/>
-          </a:prstGeom>
-          <a:noFill/>
-        </p:spPr>
-        <p:txBody>
-          <a:bodyPr wrap="square" lIns="73152" rIns="73152" tIns="36576" bIns="36576">
-            <a:spAutoFit/>
-          </a:bodyPr>
-          <a:lstStyle/>
-          <a:p>
-            <a:pPr>
-              <a:spcAft>
-                <a:spcPts val="1200"/>
-              </a:spcAft>
-            </a:pPr>
-            <a:r>
-              <a:rPr sz="2300" b="1">
+              <a:t>PRD -&gt; test cases -&gt; evidence</a:t>
+            </a:r>
+          </a:p>
+          <a:p>
+            <a:pPr>
+              <a:spcAft>
+                <a:spcPts val="1200"/>
+              </a:spcAft>
+            </a:pPr>
+            <a:r>
+              <a:rPr sz="2200" b="0">
+                <a:solidFill>
+                  <a:srgbClr val="10243A"/>
+                </a:solidFill>
+                <a:latin typeface="Arial"/>
+              </a:rPr>
+              <a:t>Both firmware versions</a:t>
+            </a:r>
+          </a:p>
+          <a:p>
+            <a:pPr>
+              <a:spcAft>
+                <a:spcPts val="1200"/>
+              </a:spcAft>
+            </a:pPr>
+            <a:r>
+              <a:rPr sz="2200" b="0">
+                <a:solidFill>
+                  <a:srgbClr val="10243A"/>
+                </a:solidFill>
+                <a:latin typeface="Arial"/>
+              </a:rPr>
+              <a:t>101 rows / 64 case IDs</a:t>
+            </a:r>
+          </a:p>
+          <a:p>
+            <a:pPr>
+              <a:spcAft>
+                <a:spcPts val="1200"/>
+              </a:spcAft>
+            </a:pPr>
+            <a:r>
+              <a:rPr sz="2200" b="0">
+                <a:solidFill>
+                  <a:srgbClr val="10243A"/>
+                </a:solidFill>
+                <a:latin typeface="Arial"/>
+              </a:rPr>
+              <a:t>Counts, not coverage %</a:t>
+            </a:r>
+          </a:p>
+        </p:txBody>
+      </p:sp>
+      <p:sp>
+        <p:nvSpPr>
+          <p:cNvPr id="10" name="TextBox 9"/>
+          <p:cNvSpPr txBox="1"/>
+          <p:nvPr/>
+        </p:nvSpPr>
+        <p:spPr>
+          <a:xfrm>
+            <a:off x="4937760" y="1965960"/>
+            <a:ext cx="1554480" cy="411480"/>
+          </a:xfrm>
+          <a:prstGeom prst="rect">
+            <a:avLst/>
+          </a:prstGeom>
+          <a:noFill/>
+        </p:spPr>
+        <p:txBody>
+          <a:bodyPr wrap="square" lIns="73152" rIns="73152" tIns="36576" bIns="36576">
+            <a:spAutoFit/>
+          </a:bodyPr>
+          <a:lstStyle/>
+          <a:p>
+            <a:pPr>
+              <a:spcAft>
+                <a:spcPts val="1200"/>
+              </a:spcAft>
+            </a:pPr>
+            <a:r>
+              <a:rPr sz="2000" b="1">
+                <a:solidFill>
+                  <a:srgbClr val="10243A"/>
+                </a:solidFill>
+                <a:latin typeface="Arial"/>
+              </a:rPr>
+              <a:t>Pass</a:t>
+            </a:r>
+          </a:p>
+        </p:txBody>
+      </p:sp>
+      <p:sp>
+        <p:nvSpPr>
+          <p:cNvPr id="11" name="Rounded Rectangle 10"/>
+          <p:cNvSpPr/>
+          <p:nvPr/>
+        </p:nvSpPr>
+        <p:spPr>
+          <a:xfrm>
+            <a:off x="6583680" y="2020824"/>
+            <a:ext cx="4389120" cy="274320"/>
+          </a:xfrm>
+          <a:prstGeom prst="roundRect">
+            <a:avLst/>
+          </a:prstGeom>
+          <a:solidFill>
+            <a:srgbClr val="E8F1F7"/>
+          </a:solidFill>
+          <a:ln>
+            <a:noFill/>
+          </a:ln>
+        </p:spPr>
+        <p:style>
+          <a:lnRef idx="1">
+            <a:schemeClr val="accent1"/>
+          </a:lnRef>
+          <a:fillRef idx="3">
+            <a:schemeClr val="accent1"/>
+          </a:fillRef>
+          <a:effectRef idx="2">
+            <a:schemeClr val="accent1"/>
+          </a:effectRef>
+          <a:fontRef idx="minor">
+            <a:schemeClr val="lt1"/>
+          </a:fontRef>
+        </p:style>
+        <p:txBody>
+          <a:bodyPr rtlCol="0" anchor="ctr"/>
+          <a:lstStyle/>
+          <a:p>
+            <a:pPr algn="ctr"/>
+          </a:p>
+        </p:txBody>
+      </p:sp>
+      <p:sp>
+        <p:nvSpPr>
+          <p:cNvPr id="12" name="Rounded Rectangle 11"/>
+          <p:cNvSpPr/>
+          <p:nvPr/>
+        </p:nvSpPr>
+        <p:spPr>
+          <a:xfrm>
+            <a:off x="6583680" y="2020824"/>
+            <a:ext cx="3511296" cy="274320"/>
+          </a:xfrm>
+          <a:prstGeom prst="roundRect">
+            <a:avLst/>
+          </a:prstGeom>
+          <a:solidFill>
+            <a:srgbClr val="166534"/>
+          </a:solidFill>
+          <a:ln>
+            <a:noFill/>
+          </a:ln>
+        </p:spPr>
+        <p:style>
+          <a:lnRef idx="1">
+            <a:schemeClr val="accent1"/>
+          </a:lnRef>
+          <a:fillRef idx="3">
+            <a:schemeClr val="accent1"/>
+          </a:fillRef>
+          <a:effectRef idx="2">
+            <a:schemeClr val="accent1"/>
+          </a:effectRef>
+          <a:fontRef idx="minor">
+            <a:schemeClr val="lt1"/>
+          </a:fontRef>
+        </p:style>
+        <p:txBody>
+          <a:bodyPr rtlCol="0" anchor="ctr"/>
+          <a:lstStyle/>
+          <a:p>
+            <a:pPr algn="ctr"/>
+          </a:p>
+        </p:txBody>
+      </p:sp>
+      <p:sp>
+        <p:nvSpPr>
+          <p:cNvPr id="13" name="TextBox 12"/>
+          <p:cNvSpPr txBox="1"/>
+          <p:nvPr/>
+        </p:nvSpPr>
+        <p:spPr>
+          <a:xfrm>
+            <a:off x="11109959" y="1965960"/>
+            <a:ext cx="594360" cy="411480"/>
+          </a:xfrm>
+          <a:prstGeom prst="rect">
+            <a:avLst/>
+          </a:prstGeom>
+          <a:noFill/>
+        </p:spPr>
+        <p:txBody>
+          <a:bodyPr wrap="square" lIns="73152" rIns="73152" tIns="36576" bIns="36576">
+            <a:spAutoFit/>
+          </a:bodyPr>
+          <a:lstStyle/>
+          <a:p>
+            <a:pPr>
+              <a:spcAft>
+                <a:spcPts val="1200"/>
+              </a:spcAft>
+            </a:pPr>
+            <a:r>
+              <a:rPr sz="2000" b="1">
+                <a:solidFill>
+                  <a:srgbClr val="166534"/>
+                </a:solidFill>
+                <a:latin typeface="Arial"/>
+              </a:rPr>
+              <a:t>40</a:t>
+            </a:r>
+          </a:p>
+        </p:txBody>
+      </p:sp>
+      <p:sp>
+        <p:nvSpPr>
+          <p:cNvPr id="14" name="TextBox 13"/>
+          <p:cNvSpPr txBox="1"/>
+          <p:nvPr/>
+        </p:nvSpPr>
+        <p:spPr>
+          <a:xfrm>
+            <a:off x="4937760" y="2606039"/>
+            <a:ext cx="1554480" cy="411480"/>
+          </a:xfrm>
+          <a:prstGeom prst="rect">
+            <a:avLst/>
+          </a:prstGeom>
+          <a:noFill/>
+        </p:spPr>
+        <p:txBody>
+          <a:bodyPr wrap="square" lIns="73152" rIns="73152" tIns="36576" bIns="36576">
+            <a:spAutoFit/>
+          </a:bodyPr>
+          <a:lstStyle/>
+          <a:p>
+            <a:pPr>
+              <a:spcAft>
+                <a:spcPts val="1200"/>
+              </a:spcAft>
+            </a:pPr>
+            <a:r>
+              <a:rPr sz="2000" b="1">
+                <a:solidFill>
+                  <a:srgbClr val="10243A"/>
+                </a:solidFill>
+                <a:latin typeface="Arial"/>
+              </a:rPr>
+              <a:t>Partial</a:t>
+            </a:r>
+          </a:p>
+        </p:txBody>
+      </p:sp>
+      <p:sp>
+        <p:nvSpPr>
+          <p:cNvPr id="15" name="Rounded Rectangle 14"/>
+          <p:cNvSpPr/>
+          <p:nvPr/>
+        </p:nvSpPr>
+        <p:spPr>
+          <a:xfrm>
+            <a:off x="6583680" y="2660903"/>
+            <a:ext cx="4389120" cy="274320"/>
+          </a:xfrm>
+          <a:prstGeom prst="roundRect">
+            <a:avLst/>
+          </a:prstGeom>
+          <a:solidFill>
+            <a:srgbClr val="E8F1F7"/>
+          </a:solidFill>
+          <a:ln>
+            <a:noFill/>
+          </a:ln>
+        </p:spPr>
+        <p:style>
+          <a:lnRef idx="1">
+            <a:schemeClr val="accent1"/>
+          </a:lnRef>
+          <a:fillRef idx="3">
+            <a:schemeClr val="accent1"/>
+          </a:fillRef>
+          <a:effectRef idx="2">
+            <a:schemeClr val="accent1"/>
+          </a:effectRef>
+          <a:fontRef idx="minor">
+            <a:schemeClr val="lt1"/>
+          </a:fontRef>
+        </p:style>
+        <p:txBody>
+          <a:bodyPr rtlCol="0" anchor="ctr"/>
+          <a:lstStyle/>
+          <a:p>
+            <a:pPr algn="ctr"/>
+          </a:p>
+        </p:txBody>
+      </p:sp>
+      <p:sp>
+        <p:nvSpPr>
+          <p:cNvPr id="16" name="Rounded Rectangle 15"/>
+          <p:cNvSpPr/>
+          <p:nvPr/>
+        </p:nvSpPr>
+        <p:spPr>
+          <a:xfrm>
+            <a:off x="6583680" y="2660903"/>
+            <a:ext cx="4125772" cy="274320"/>
+          </a:xfrm>
+          <a:prstGeom prst="roundRect">
+            <a:avLst/>
+          </a:prstGeom>
+          <a:solidFill>
+            <a:srgbClr val="075985"/>
+          </a:solidFill>
+          <a:ln>
+            <a:noFill/>
+          </a:ln>
+        </p:spPr>
+        <p:style>
+          <a:lnRef idx="1">
+            <a:schemeClr val="accent1"/>
+          </a:lnRef>
+          <a:fillRef idx="3">
+            <a:schemeClr val="accent1"/>
+          </a:fillRef>
+          <a:effectRef idx="2">
+            <a:schemeClr val="accent1"/>
+          </a:effectRef>
+          <a:fontRef idx="minor">
+            <a:schemeClr val="lt1"/>
+          </a:fontRef>
+        </p:style>
+        <p:txBody>
+          <a:bodyPr rtlCol="0" anchor="ctr"/>
+          <a:lstStyle/>
+          <a:p>
+            <a:pPr algn="ctr"/>
+          </a:p>
+        </p:txBody>
+      </p:sp>
+      <p:sp>
+        <p:nvSpPr>
+          <p:cNvPr id="17" name="TextBox 16"/>
+          <p:cNvSpPr txBox="1"/>
+          <p:nvPr/>
+        </p:nvSpPr>
+        <p:spPr>
+          <a:xfrm>
+            <a:off x="11109959" y="2606039"/>
+            <a:ext cx="594360" cy="411480"/>
+          </a:xfrm>
+          <a:prstGeom prst="rect">
+            <a:avLst/>
+          </a:prstGeom>
+          <a:noFill/>
+        </p:spPr>
+        <p:txBody>
+          <a:bodyPr wrap="square" lIns="73152" rIns="73152" tIns="36576" bIns="36576">
+            <a:spAutoFit/>
+          </a:bodyPr>
+          <a:lstStyle/>
+          <a:p>
+            <a:pPr>
+              <a:spcAft>
+                <a:spcPts val="1200"/>
+              </a:spcAft>
+            </a:pPr>
+            <a:r>
+              <a:rPr sz="2000" b="1">
                 <a:solidFill>
                   <a:srgbClr val="075985"/>
                 </a:solidFill>
                 <a:latin typeface="Arial"/>
               </a:rPr>
-              <a:t>-</a:t>
-            </a:r>
-          </a:p>
-        </p:txBody>
-      </p:sp>
-      <p:sp>
-        <p:nvSpPr>
-          <p:cNvPr id="10" name="TextBox 9"/>
-          <p:cNvSpPr txBox="1"/>
-          <p:nvPr/>
-        </p:nvSpPr>
-        <p:spPr>
-          <a:xfrm>
-            <a:off x="914400" y="2596896"/>
-            <a:ext cx="10607040" cy="704088"/>
-          </a:xfrm>
-          <a:prstGeom prst="rect">
-            <a:avLst/>
-          </a:prstGeom>
-          <a:noFill/>
-        </p:spPr>
-        <p:txBody>
-          <a:bodyPr wrap="square" lIns="73152" rIns="73152" tIns="36576" bIns="36576">
-            <a:spAutoFit/>
-          </a:bodyPr>
-          <a:lstStyle/>
-          <a:p>
-            <a:pPr>
-              <a:spcAft>
-                <a:spcPts val="1200"/>
-              </a:spcAft>
-            </a:pPr>
-            <a:r>
-              <a:rPr sz="2300" b="0">
+              <a:t>47</a:t>
+            </a:r>
+          </a:p>
+        </p:txBody>
+      </p:sp>
+      <p:sp>
+        <p:nvSpPr>
+          <p:cNvPr id="18" name="TextBox 17"/>
+          <p:cNvSpPr txBox="1"/>
+          <p:nvPr/>
+        </p:nvSpPr>
+        <p:spPr>
+          <a:xfrm>
+            <a:off x="4937760" y="3246120"/>
+            <a:ext cx="1554480" cy="411480"/>
+          </a:xfrm>
+          <a:prstGeom prst="rect">
+            <a:avLst/>
+          </a:prstGeom>
+          <a:noFill/>
+        </p:spPr>
+        <p:txBody>
+          <a:bodyPr wrap="square" lIns="73152" rIns="73152" tIns="36576" bIns="36576">
+            <a:spAutoFit/>
+          </a:bodyPr>
+          <a:lstStyle/>
+          <a:p>
+            <a:pPr>
+              <a:spcAft>
+                <a:spcPts val="1200"/>
+              </a:spcAft>
+            </a:pPr>
+            <a:r>
+              <a:rPr sz="2000" b="1">
                 <a:solidFill>
                   <a:srgbClr val="10243A"/>
                 </a:solidFill>
                 <a:latin typeface="Arial"/>
               </a:rPr>
-              <a:t>Both versions: normal, boundary, invalid-input, persistence and OTA checks.</a:t>
-            </a:r>
-          </a:p>
-        </p:txBody>
-      </p:sp>
-      <p:sp>
-        <p:nvSpPr>
-          <p:cNvPr id="11" name="TextBox 10"/>
-          <p:cNvSpPr txBox="1"/>
-          <p:nvPr/>
-        </p:nvSpPr>
-        <p:spPr>
-          <a:xfrm>
-            <a:off x="594360" y="3364991"/>
-            <a:ext cx="274320" cy="457200"/>
-          </a:xfrm>
-          <a:prstGeom prst="rect">
-            <a:avLst/>
-          </a:prstGeom>
-          <a:noFill/>
-        </p:spPr>
-        <p:txBody>
-          <a:bodyPr wrap="square" lIns="73152" rIns="73152" tIns="36576" bIns="36576">
-            <a:spAutoFit/>
-          </a:bodyPr>
-          <a:lstStyle/>
-          <a:p>
-            <a:pPr>
-              <a:spcAft>
-                <a:spcPts val="1200"/>
-              </a:spcAft>
-            </a:pPr>
-            <a:r>
-              <a:rPr sz="2300" b="1">
-                <a:solidFill>
-                  <a:srgbClr val="075985"/>
-                </a:solidFill>
-                <a:latin typeface="Arial"/>
-              </a:rPr>
-              <a:t>-</a:t>
-            </a:r>
-          </a:p>
-        </p:txBody>
-      </p:sp>
-      <p:sp>
-        <p:nvSpPr>
-          <p:cNvPr id="12" name="TextBox 11"/>
-          <p:cNvSpPr txBox="1"/>
-          <p:nvPr/>
-        </p:nvSpPr>
-        <p:spPr>
-          <a:xfrm>
-            <a:off x="914400" y="3364991"/>
-            <a:ext cx="10607040" cy="704088"/>
-          </a:xfrm>
-          <a:prstGeom prst="rect">
-            <a:avLst/>
-          </a:prstGeom>
-          <a:noFill/>
-        </p:spPr>
-        <p:txBody>
-          <a:bodyPr wrap="square" lIns="73152" rIns="73152" tIns="36576" bIns="36576">
-            <a:spAutoFit/>
-          </a:bodyPr>
-          <a:lstStyle/>
-          <a:p>
-            <a:pPr>
-              <a:spcAft>
-                <a:spcPts val="1200"/>
-              </a:spcAft>
-            </a:pPr>
-            <a:r>
-              <a:rPr sz="2300" b="0">
+              <a:t>Fail</a:t>
+            </a:r>
+          </a:p>
+        </p:txBody>
+      </p:sp>
+      <p:sp>
+        <p:nvSpPr>
+          <p:cNvPr id="19" name="Rounded Rectangle 18"/>
+          <p:cNvSpPr/>
+          <p:nvPr/>
+        </p:nvSpPr>
+        <p:spPr>
+          <a:xfrm>
+            <a:off x="6583680" y="3300984"/>
+            <a:ext cx="4389120" cy="274320"/>
+          </a:xfrm>
+          <a:prstGeom prst="roundRect">
+            <a:avLst/>
+          </a:prstGeom>
+          <a:solidFill>
+            <a:srgbClr val="E8F1F7"/>
+          </a:solidFill>
+          <a:ln>
+            <a:noFill/>
+          </a:ln>
+        </p:spPr>
+        <p:style>
+          <a:lnRef idx="1">
+            <a:schemeClr val="accent1"/>
+          </a:lnRef>
+          <a:fillRef idx="3">
+            <a:schemeClr val="accent1"/>
+          </a:fillRef>
+          <a:effectRef idx="2">
+            <a:schemeClr val="accent1"/>
+          </a:effectRef>
+          <a:fontRef idx="minor">
+            <a:schemeClr val="lt1"/>
+          </a:fontRef>
+        </p:style>
+        <p:txBody>
+          <a:bodyPr rtlCol="0" anchor="ctr"/>
+          <a:lstStyle/>
+          <a:p>
+            <a:pPr algn="ctr"/>
+          </a:p>
+        </p:txBody>
+      </p:sp>
+      <p:sp>
+        <p:nvSpPr>
+          <p:cNvPr id="20" name="Rounded Rectangle 19"/>
+          <p:cNvSpPr/>
+          <p:nvPr/>
+        </p:nvSpPr>
+        <p:spPr>
+          <a:xfrm>
+            <a:off x="6583680" y="3300984"/>
+            <a:ext cx="965606" cy="274320"/>
+          </a:xfrm>
+          <a:prstGeom prst="roundRect">
+            <a:avLst/>
+          </a:prstGeom>
+          <a:solidFill>
+            <a:srgbClr val="991B1B"/>
+          </a:solidFill>
+          <a:ln>
+            <a:noFill/>
+          </a:ln>
+        </p:spPr>
+        <p:style>
+          <a:lnRef idx="1">
+            <a:schemeClr val="accent1"/>
+          </a:lnRef>
+          <a:fillRef idx="3">
+            <a:schemeClr val="accent1"/>
+          </a:fillRef>
+          <a:effectRef idx="2">
+            <a:schemeClr val="accent1"/>
+          </a:effectRef>
+          <a:fontRef idx="minor">
+            <a:schemeClr val="lt1"/>
+          </a:fontRef>
+        </p:style>
+        <p:txBody>
+          <a:bodyPr rtlCol="0" anchor="ctr"/>
+          <a:lstStyle/>
+          <a:p>
+            <a:pPr algn="ctr"/>
+          </a:p>
+        </p:txBody>
+      </p:sp>
+      <p:sp>
+        <p:nvSpPr>
+          <p:cNvPr id="21" name="TextBox 20"/>
+          <p:cNvSpPr txBox="1"/>
+          <p:nvPr/>
+        </p:nvSpPr>
+        <p:spPr>
+          <a:xfrm>
+            <a:off x="11109959" y="3246120"/>
+            <a:ext cx="594360" cy="411480"/>
+          </a:xfrm>
+          <a:prstGeom prst="rect">
+            <a:avLst/>
+          </a:prstGeom>
+          <a:noFill/>
+        </p:spPr>
+        <p:txBody>
+          <a:bodyPr wrap="square" lIns="73152" rIns="73152" tIns="36576" bIns="36576">
+            <a:spAutoFit/>
+          </a:bodyPr>
+          <a:lstStyle/>
+          <a:p>
+            <a:pPr>
+              <a:spcAft>
+                <a:spcPts val="1200"/>
+              </a:spcAft>
+            </a:pPr>
+            <a:r>
+              <a:rPr sz="2000" b="1">
+                <a:solidFill>
+                  <a:srgbClr val="991B1B"/>
+                </a:solidFill>
+                <a:latin typeface="Arial"/>
+              </a:rPr>
+              <a:t>11</a:t>
+            </a:r>
+          </a:p>
+        </p:txBody>
+      </p:sp>
+      <p:sp>
+        <p:nvSpPr>
+          <p:cNvPr id="22" name="TextBox 21"/>
+          <p:cNvSpPr txBox="1"/>
+          <p:nvPr/>
+        </p:nvSpPr>
+        <p:spPr>
+          <a:xfrm>
+            <a:off x="4937760" y="3886200"/>
+            <a:ext cx="1554480" cy="411480"/>
+          </a:xfrm>
+          <a:prstGeom prst="rect">
+            <a:avLst/>
+          </a:prstGeom>
+          <a:noFill/>
+        </p:spPr>
+        <p:txBody>
+          <a:bodyPr wrap="square" lIns="73152" rIns="73152" tIns="36576" bIns="36576">
+            <a:spAutoFit/>
+          </a:bodyPr>
+          <a:lstStyle/>
+          <a:p>
+            <a:pPr>
+              <a:spcAft>
+                <a:spcPts val="1200"/>
+              </a:spcAft>
+            </a:pPr>
+            <a:r>
+              <a:rPr sz="2000" b="1">
                 <a:solidFill>
                   <a:srgbClr val="10243A"/>
                 </a:solidFill>
                 <a:latin typeface="Arial"/>
               </a:rPr>
-              <a:t>101 recorded rows across 64 case IDs; not a coverage percentage.</a:t>
-            </a:r>
-          </a:p>
-        </p:txBody>
-      </p:sp>
-      <p:sp>
-        <p:nvSpPr>
-          <p:cNvPr id="13" name="TextBox 12"/>
-          <p:cNvSpPr txBox="1"/>
-          <p:nvPr/>
-        </p:nvSpPr>
-        <p:spPr>
-          <a:xfrm>
-            <a:off x="594360" y="4133087"/>
-            <a:ext cx="274320" cy="457200"/>
-          </a:xfrm>
-          <a:prstGeom prst="rect">
-            <a:avLst/>
-          </a:prstGeom>
-          <a:noFill/>
-        </p:spPr>
-        <p:txBody>
-          <a:bodyPr wrap="square" lIns="73152" rIns="73152" tIns="36576" bIns="36576">
-            <a:spAutoFit/>
-          </a:bodyPr>
-          <a:lstStyle/>
-          <a:p>
-            <a:pPr>
-              <a:spcAft>
-                <a:spcPts val="1200"/>
-              </a:spcAft>
-            </a:pPr>
-            <a:r>
-              <a:rPr sz="2300" b="1">
-                <a:solidFill>
-                  <a:srgbClr val="075985"/>
-                </a:solidFill>
-                <a:latin typeface="Arial"/>
-              </a:rPr>
-              <a:t>-</a:t>
-            </a:r>
-          </a:p>
-        </p:txBody>
-      </p:sp>
-      <p:sp>
-        <p:nvSpPr>
-          <p:cNvPr id="14" name="TextBox 13"/>
-          <p:cNvSpPr txBox="1"/>
-          <p:nvPr/>
-        </p:nvSpPr>
-        <p:spPr>
-          <a:xfrm>
-            <a:off x="914400" y="4133087"/>
-            <a:ext cx="10607040" cy="704088"/>
-          </a:xfrm>
-          <a:prstGeom prst="rect">
-            <a:avLst/>
-          </a:prstGeom>
-          <a:noFill/>
-        </p:spPr>
-        <p:txBody>
-          <a:bodyPr wrap="square" lIns="73152" rIns="73152" tIns="36576" bIns="36576">
-            <a:spAutoFit/>
-          </a:bodyPr>
-          <a:lstStyle/>
-          <a:p>
-            <a:pPr>
-              <a:spcAft>
-                <a:spcPts val="1200"/>
-              </a:spcAft>
-            </a:pPr>
-            <a:r>
-              <a:rPr sz="2300" b="0">
+              <a:t>Investigate</a:t>
+            </a:r>
+          </a:p>
+        </p:txBody>
+      </p:sp>
+      <p:sp>
+        <p:nvSpPr>
+          <p:cNvPr id="23" name="Rounded Rectangle 22"/>
+          <p:cNvSpPr/>
+          <p:nvPr/>
+        </p:nvSpPr>
+        <p:spPr>
+          <a:xfrm>
+            <a:off x="6583680" y="3941063"/>
+            <a:ext cx="4389120" cy="274320"/>
+          </a:xfrm>
+          <a:prstGeom prst="roundRect">
+            <a:avLst/>
+          </a:prstGeom>
+          <a:solidFill>
+            <a:srgbClr val="E8F1F7"/>
+          </a:solidFill>
+          <a:ln>
+            <a:noFill/>
+          </a:ln>
+        </p:spPr>
+        <p:style>
+          <a:lnRef idx="1">
+            <a:schemeClr val="accent1"/>
+          </a:lnRef>
+          <a:fillRef idx="3">
+            <a:schemeClr val="accent1"/>
+          </a:fillRef>
+          <a:effectRef idx="2">
+            <a:schemeClr val="accent1"/>
+          </a:effectRef>
+          <a:fontRef idx="minor">
+            <a:schemeClr val="lt1"/>
+          </a:fontRef>
+        </p:style>
+        <p:txBody>
+          <a:bodyPr rtlCol="0" anchor="ctr"/>
+          <a:lstStyle/>
+          <a:p>
+            <a:pPr algn="ctr"/>
+          </a:p>
+        </p:txBody>
+      </p:sp>
+      <p:sp>
+        <p:nvSpPr>
+          <p:cNvPr id="24" name="Rounded Rectangle 23"/>
+          <p:cNvSpPr/>
+          <p:nvPr/>
+        </p:nvSpPr>
+        <p:spPr>
+          <a:xfrm>
+            <a:off x="6583680" y="3941063"/>
+            <a:ext cx="175564" cy="274320"/>
+          </a:xfrm>
+          <a:prstGeom prst="roundRect">
+            <a:avLst/>
+          </a:prstGeom>
+          <a:solidFill>
+            <a:srgbClr val="854D0E"/>
+          </a:solidFill>
+          <a:ln>
+            <a:noFill/>
+          </a:ln>
+        </p:spPr>
+        <p:style>
+          <a:lnRef idx="1">
+            <a:schemeClr val="accent1"/>
+          </a:lnRef>
+          <a:fillRef idx="3">
+            <a:schemeClr val="accent1"/>
+          </a:fillRef>
+          <a:effectRef idx="2">
+            <a:schemeClr val="accent1"/>
+          </a:effectRef>
+          <a:fontRef idx="minor">
+            <a:schemeClr val="lt1"/>
+          </a:fontRef>
+        </p:style>
+        <p:txBody>
+          <a:bodyPr rtlCol="0" anchor="ctr"/>
+          <a:lstStyle/>
+          <a:p>
+            <a:pPr algn="ctr"/>
+          </a:p>
+        </p:txBody>
+      </p:sp>
+      <p:sp>
+        <p:nvSpPr>
+          <p:cNvPr id="25" name="TextBox 24"/>
+          <p:cNvSpPr txBox="1"/>
+          <p:nvPr/>
+        </p:nvSpPr>
+        <p:spPr>
+          <a:xfrm>
+            <a:off x="11109959" y="3886200"/>
+            <a:ext cx="594360" cy="411480"/>
+          </a:xfrm>
+          <a:prstGeom prst="rect">
+            <a:avLst/>
+          </a:prstGeom>
+          <a:noFill/>
+        </p:spPr>
+        <p:txBody>
+          <a:bodyPr wrap="square" lIns="73152" rIns="73152" tIns="36576" bIns="36576">
+            <a:spAutoFit/>
+          </a:bodyPr>
+          <a:lstStyle/>
+          <a:p>
+            <a:pPr>
+              <a:spcAft>
+                <a:spcPts val="1200"/>
+              </a:spcAft>
+            </a:pPr>
+            <a:r>
+              <a:rPr sz="2000" b="1">
+                <a:solidFill>
+                  <a:srgbClr val="854D0E"/>
+                </a:solidFill>
+                <a:latin typeface="Arial"/>
+              </a:rPr>
+              <a:t>2</a:t>
+            </a:r>
+          </a:p>
+        </p:txBody>
+      </p:sp>
+      <p:sp>
+        <p:nvSpPr>
+          <p:cNvPr id="26" name="TextBox 25"/>
+          <p:cNvSpPr txBox="1"/>
+          <p:nvPr/>
+        </p:nvSpPr>
+        <p:spPr>
+          <a:xfrm>
+            <a:off x="4937760" y="4526279"/>
+            <a:ext cx="1554480" cy="411480"/>
+          </a:xfrm>
+          <a:prstGeom prst="rect">
+            <a:avLst/>
+          </a:prstGeom>
+          <a:noFill/>
+        </p:spPr>
+        <p:txBody>
+          <a:bodyPr wrap="square" lIns="73152" rIns="73152" tIns="36576" bIns="36576">
+            <a:spAutoFit/>
+          </a:bodyPr>
+          <a:lstStyle/>
+          <a:p>
+            <a:pPr>
+              <a:spcAft>
+                <a:spcPts val="1200"/>
+              </a:spcAft>
+            </a:pPr>
+            <a:r>
+              <a:rPr sz="2000" b="1">
                 <a:solidFill>
                   <a:srgbClr val="10243A"/>
                 </a:solidFill>
                 <a:latin typeface="Arial"/>
               </a:rPr>
-              <a:t>40 Pass | 47 Partial | 11 Fail | 2 Investigate | 1 Not run.</a:t>
-            </a:r>
-          </a:p>
-        </p:txBody>
-      </p:sp>
-      <p:sp>
-        <p:nvSpPr>
-          <p:cNvPr id="15" name="TextBox 14"/>
-          <p:cNvSpPr txBox="1"/>
-          <p:nvPr/>
-        </p:nvSpPr>
-        <p:spPr>
-          <a:xfrm>
-            <a:off x="594360" y="4901183"/>
-            <a:ext cx="274320" cy="457200"/>
-          </a:xfrm>
-          <a:prstGeom prst="rect">
-            <a:avLst/>
-          </a:prstGeom>
-          <a:noFill/>
-        </p:spPr>
-        <p:txBody>
-          <a:bodyPr wrap="square" lIns="73152" rIns="73152" tIns="36576" bIns="36576">
-            <a:spAutoFit/>
-          </a:bodyPr>
-          <a:lstStyle/>
-          <a:p>
-            <a:pPr>
-              <a:spcAft>
-                <a:spcPts val="1200"/>
-              </a:spcAft>
-            </a:pPr>
-            <a:r>
-              <a:rPr sz="2300" b="1">
-                <a:solidFill>
-                  <a:srgbClr val="075985"/>
-                </a:solidFill>
-                <a:latin typeface="Arial"/>
-              </a:rPr>
-              <a:t>-</a:t>
-            </a:r>
-          </a:p>
-        </p:txBody>
-      </p:sp>
-      <p:sp>
-        <p:nvSpPr>
-          <p:cNvPr id="16" name="TextBox 15"/>
-          <p:cNvSpPr txBox="1"/>
-          <p:nvPr/>
-        </p:nvSpPr>
-        <p:spPr>
-          <a:xfrm>
-            <a:off x="914400" y="4901183"/>
-            <a:ext cx="10607040" cy="704088"/>
-          </a:xfrm>
-          <a:prstGeom prst="rect">
-            <a:avLst/>
-          </a:prstGeom>
-          <a:noFill/>
-        </p:spPr>
-        <p:txBody>
-          <a:bodyPr wrap="square" lIns="73152" rIns="73152" tIns="36576" bIns="36576">
-            <a:spAutoFit/>
-          </a:bodyPr>
-          <a:lstStyle/>
-          <a:p>
-            <a:pPr>
-              <a:spcAft>
-                <a:spcPts val="1200"/>
-              </a:spcAft>
-            </a:pPr>
-            <a:r>
-              <a:rPr sz="2300" b="0">
+              <a:t>Not run</a:t>
+            </a:r>
+          </a:p>
+        </p:txBody>
+      </p:sp>
+      <p:sp>
+        <p:nvSpPr>
+          <p:cNvPr id="27" name="Rounded Rectangle 26"/>
+          <p:cNvSpPr/>
+          <p:nvPr/>
+        </p:nvSpPr>
+        <p:spPr>
+          <a:xfrm>
+            <a:off x="6583680" y="4581143"/>
+            <a:ext cx="4389120" cy="274320"/>
+          </a:xfrm>
+          <a:prstGeom prst="roundRect">
+            <a:avLst/>
+          </a:prstGeom>
+          <a:solidFill>
+            <a:srgbClr val="E8F1F7"/>
+          </a:solidFill>
+          <a:ln>
+            <a:noFill/>
+          </a:ln>
+        </p:spPr>
+        <p:style>
+          <a:lnRef idx="1">
+            <a:schemeClr val="accent1"/>
+          </a:lnRef>
+          <a:fillRef idx="3">
+            <a:schemeClr val="accent1"/>
+          </a:fillRef>
+          <a:effectRef idx="2">
+            <a:schemeClr val="accent1"/>
+          </a:effectRef>
+          <a:fontRef idx="minor">
+            <a:schemeClr val="lt1"/>
+          </a:fontRef>
+        </p:style>
+        <p:txBody>
+          <a:bodyPr rtlCol="0" anchor="ctr"/>
+          <a:lstStyle/>
+          <a:p>
+            <a:pPr algn="ctr"/>
+          </a:p>
+        </p:txBody>
+      </p:sp>
+      <p:sp>
+        <p:nvSpPr>
+          <p:cNvPr id="28" name="Rounded Rectangle 27"/>
+          <p:cNvSpPr/>
+          <p:nvPr/>
+        </p:nvSpPr>
+        <p:spPr>
+          <a:xfrm>
+            <a:off x="6583680" y="4581143"/>
+            <a:ext cx="87782" cy="274320"/>
+          </a:xfrm>
+          <a:prstGeom prst="roundRect">
+            <a:avLst/>
+          </a:prstGeom>
+          <a:solidFill>
+            <a:srgbClr val="475569"/>
+          </a:solidFill>
+          <a:ln>
+            <a:noFill/>
+          </a:ln>
+        </p:spPr>
+        <p:style>
+          <a:lnRef idx="1">
+            <a:schemeClr val="accent1"/>
+          </a:lnRef>
+          <a:fillRef idx="3">
+            <a:schemeClr val="accent1"/>
+          </a:fillRef>
+          <a:effectRef idx="2">
+            <a:schemeClr val="accent1"/>
+          </a:effectRef>
+          <a:fontRef idx="minor">
+            <a:schemeClr val="lt1"/>
+          </a:fontRef>
+        </p:style>
+        <p:txBody>
+          <a:bodyPr rtlCol="0" anchor="ctr"/>
+          <a:lstStyle/>
+          <a:p>
+            <a:pPr algn="ctr"/>
+          </a:p>
+        </p:txBody>
+      </p:sp>
+      <p:sp>
+        <p:nvSpPr>
+          <p:cNvPr id="29" name="TextBox 28"/>
+          <p:cNvSpPr txBox="1"/>
+          <p:nvPr/>
+        </p:nvSpPr>
+        <p:spPr>
+          <a:xfrm>
+            <a:off x="11109959" y="4526279"/>
+            <a:ext cx="594360" cy="411480"/>
+          </a:xfrm>
+          <a:prstGeom prst="rect">
+            <a:avLst/>
+          </a:prstGeom>
+          <a:noFill/>
+        </p:spPr>
+        <p:txBody>
+          <a:bodyPr wrap="square" lIns="73152" rIns="73152" tIns="36576" bIns="36576">
+            <a:spAutoFit/>
+          </a:bodyPr>
+          <a:lstStyle/>
+          <a:p>
+            <a:pPr>
+              <a:spcAft>
+                <a:spcPts val="1200"/>
+              </a:spcAft>
+            </a:pPr>
+            <a:r>
+              <a:rPr sz="2000" b="1">
+                <a:solidFill>
+                  <a:srgbClr val="475569"/>
+                </a:solidFill>
+                <a:latin typeface="Arial"/>
+              </a:rPr>
+              <a:t>1</a:t>
+            </a:r>
+          </a:p>
+        </p:txBody>
+      </p:sp>
+      <p:sp>
+        <p:nvSpPr>
+          <p:cNvPr id="30" name="TextBox 29"/>
+          <p:cNvSpPr txBox="1"/>
+          <p:nvPr/>
+        </p:nvSpPr>
+        <p:spPr>
+          <a:xfrm>
+            <a:off x="594360" y="5669280"/>
+            <a:ext cx="10972800" cy="457200"/>
+          </a:xfrm>
+          <a:prstGeom prst="rect">
+            <a:avLst/>
+          </a:prstGeom>
+          <a:noFill/>
+        </p:spPr>
+        <p:txBody>
+          <a:bodyPr wrap="square" lIns="73152" rIns="73152" tIns="36576" bIns="36576">
+            <a:spAutoFit/>
+          </a:bodyPr>
+          <a:lstStyle/>
+          <a:p>
+            <a:pPr>
+              <a:spcAft>
+                <a:spcPts val="1200"/>
+              </a:spcAft>
+            </a:pPr>
+            <a:r>
+              <a:rPr sz="2100" b="0">
                 <a:solidFill>
                   <a:srgbClr val="10243A"/>
                 </a:solidFill>
                 <a:latin typeface="Arial"/>
               </a:rPr>
-              <a:t>Separate Oct 23 supplement: 4 automated tests on real firmware 2.3.0.</a:t>
+              <a:t>Separate Oct 23 supplement: 4 automated tests on actual firmware 2.3.0.</a:t>
             </a:r>
           </a:p>
         </p:txBody>
@@ -5453,16 +6091,40 @@
           </a:p>
         </p:txBody>
       </p:sp>
-      <p:sp>
-        <p:nvSpPr>
-          <p:cNvPr id="7" name="TextBox 6"/>
-          <p:cNvSpPr txBox="1"/>
-          <p:nvPr/>
-        </p:nvSpPr>
-        <p:spPr>
-          <a:xfrm>
-            <a:off x="594360" y="1828800"/>
-            <a:ext cx="274320" cy="457200"/>
+      <p:pic>
+        <p:nvPicPr>
+          <p:cNvPr id="7" name="Picture 6" descr="photo_2026-10-23_20-38-09.jpg"/>
+          <p:cNvPicPr>
+            <a:picLocks noChangeAspect="1"/>
+          </p:cNvPicPr>
+          <p:nvPr/>
+        </p:nvPicPr>
+        <p:blipFill>
+          <a:blip r:embed="rId2"/>
+          <a:stretch>
+            <a:fillRect/>
+          </a:stretch>
+        </p:blipFill>
+        <p:spPr>
+          <a:xfrm>
+            <a:off x="594360" y="1874519"/>
+            <a:ext cx="3474720" cy="2584323"/>
+          </a:xfrm>
+          <a:prstGeom prst="rect">
+            <a:avLst/>
+          </a:prstGeom>
+        </p:spPr>
+      </p:pic>
+      <p:sp>
+        <p:nvSpPr>
+          <p:cNvPr id="8" name="TextBox 7"/>
+          <p:cNvSpPr txBox="1"/>
+          <p:nvPr/>
+        </p:nvSpPr>
+        <p:spPr>
+          <a:xfrm>
+            <a:off x="594360" y="4572000"/>
+            <a:ext cx="3474720" cy="411480"/>
           </a:xfrm>
           <a:prstGeom prst="rect">
             <a:avLst/>
@@ -5483,440 +6145,215 @@
             <a:r>
               <a:rPr sz="2200" b="1">
                 <a:solidFill>
+                  <a:srgbClr val="991B1B"/>
+                </a:solidFill>
+                <a:latin typeface="Arial"/>
+              </a:rPr>
+              <a:t>RED  (255, 0, 0)</a:t>
+            </a:r>
+          </a:p>
+        </p:txBody>
+      </p:sp>
+      <p:pic>
+        <p:nvPicPr>
+          <p:cNvPr id="9" name="Picture 8" descr="photo_2026-10-23_20-38-05.jpg"/>
+          <p:cNvPicPr>
+            <a:picLocks noChangeAspect="1"/>
+          </p:cNvPicPr>
+          <p:nvPr/>
+        </p:nvPicPr>
+        <p:blipFill>
+          <a:blip r:embed="rId3"/>
+          <a:stretch>
+            <a:fillRect/>
+          </a:stretch>
+        </p:blipFill>
+        <p:spPr>
+          <a:xfrm>
+            <a:off x="4361688" y="1874519"/>
+            <a:ext cx="3474720" cy="2584323"/>
+          </a:xfrm>
+          <a:prstGeom prst="rect">
+            <a:avLst/>
+          </a:prstGeom>
+        </p:spPr>
+      </p:pic>
+      <p:sp>
+        <p:nvSpPr>
+          <p:cNvPr id="10" name="TextBox 9"/>
+          <p:cNvSpPr txBox="1"/>
+          <p:nvPr/>
+        </p:nvSpPr>
+        <p:spPr>
+          <a:xfrm>
+            <a:off x="4361688" y="4572000"/>
+            <a:ext cx="3474720" cy="411480"/>
+          </a:xfrm>
+          <a:prstGeom prst="rect">
+            <a:avLst/>
+          </a:prstGeom>
+          <a:noFill/>
+        </p:spPr>
+        <p:txBody>
+          <a:bodyPr wrap="square" lIns="73152" rIns="73152" tIns="36576" bIns="36576">
+            <a:spAutoFit/>
+          </a:bodyPr>
+          <a:lstStyle/>
+          <a:p>
+            <a:pPr>
+              <a:spcAft>
+                <a:spcPts val="1200"/>
+              </a:spcAft>
+            </a:pPr>
+            <a:r>
+              <a:rPr sz="2200" b="1">
+                <a:solidFill>
+                  <a:srgbClr val="166534"/>
+                </a:solidFill>
+                <a:latin typeface="Arial"/>
+              </a:rPr>
+              <a:t>GREEN  (0, 255, 0)</a:t>
+            </a:r>
+          </a:p>
+        </p:txBody>
+      </p:sp>
+      <p:pic>
+        <p:nvPicPr>
+          <p:cNvPr id="11" name="Picture 10" descr="photo_2026-10-23_20-37-59.jpg"/>
+          <p:cNvPicPr>
+            <a:picLocks noChangeAspect="1"/>
+          </p:cNvPicPr>
+          <p:nvPr/>
+        </p:nvPicPr>
+        <p:blipFill>
+          <a:blip r:embed="rId4"/>
+          <a:stretch>
+            <a:fillRect/>
+          </a:stretch>
+        </p:blipFill>
+        <p:spPr>
+          <a:xfrm>
+            <a:off x="8129016" y="1874519"/>
+            <a:ext cx="3474720" cy="2584323"/>
+          </a:xfrm>
+          <a:prstGeom prst="rect">
+            <a:avLst/>
+          </a:prstGeom>
+        </p:spPr>
+      </p:pic>
+      <p:sp>
+        <p:nvSpPr>
+          <p:cNvPr id="12" name="TextBox 11"/>
+          <p:cNvSpPr txBox="1"/>
+          <p:nvPr/>
+        </p:nvSpPr>
+        <p:spPr>
+          <a:xfrm>
+            <a:off x="8129016" y="4572000"/>
+            <a:ext cx="3474720" cy="411480"/>
+          </a:xfrm>
+          <a:prstGeom prst="rect">
+            <a:avLst/>
+          </a:prstGeom>
+          <a:noFill/>
+        </p:spPr>
+        <p:txBody>
+          <a:bodyPr wrap="square" lIns="73152" rIns="73152" tIns="36576" bIns="36576">
+            <a:spAutoFit/>
+          </a:bodyPr>
+          <a:lstStyle/>
+          <a:p>
+            <a:pPr>
+              <a:spcAft>
+                <a:spcPts val="1200"/>
+              </a:spcAft>
+            </a:pPr>
+            <a:r>
+              <a:rPr sz="2200" b="1">
+                <a:solidFill>
                   <a:srgbClr val="075985"/>
                 </a:solidFill>
                 <a:latin typeface="Arial"/>
               </a:rPr>
-              <a:t>-</a:t>
-            </a:r>
-          </a:p>
-        </p:txBody>
-      </p:sp>
-      <p:sp>
-        <p:nvSpPr>
-          <p:cNvPr id="8" name="TextBox 7"/>
-          <p:cNvSpPr txBox="1"/>
-          <p:nvPr/>
-        </p:nvSpPr>
-        <p:spPr>
-          <a:xfrm>
-            <a:off x="914400" y="1828800"/>
-            <a:ext cx="10607040" cy="603503"/>
-          </a:xfrm>
-          <a:prstGeom prst="rect">
-            <a:avLst/>
-          </a:prstGeom>
-          <a:noFill/>
-        </p:spPr>
-        <p:txBody>
-          <a:bodyPr wrap="square" lIns="73152" rIns="73152" tIns="36576" bIns="36576">
-            <a:spAutoFit/>
-          </a:bodyPr>
-          <a:lstStyle/>
-          <a:p>
-            <a:pPr>
-              <a:spcAft>
-                <a:spcPts val="1200"/>
-              </a:spcAft>
-            </a:pPr>
-            <a:r>
-              <a:rPr sz="2200" b="0">
+              <a:t>BLUE  (0, 0, 255)</a:t>
+            </a:r>
+          </a:p>
+        </p:txBody>
+      </p:sp>
+      <p:sp>
+        <p:nvSpPr>
+          <p:cNvPr id="13" name="TextBox 12"/>
+          <p:cNvSpPr txBox="1"/>
+          <p:nvPr/>
+        </p:nvSpPr>
+        <p:spPr>
+          <a:xfrm>
+            <a:off x="594360" y="5166360"/>
+            <a:ext cx="10972800" cy="457200"/>
+          </a:xfrm>
+          <a:prstGeom prst="rect">
+            <a:avLst/>
+          </a:prstGeom>
+          <a:noFill/>
+        </p:spPr>
+        <p:txBody>
+          <a:bodyPr wrap="square" lIns="73152" rIns="73152" tIns="36576" bIns="36576">
+            <a:spAutoFit/>
+          </a:bodyPr>
+          <a:lstStyle/>
+          <a:p>
+            <a:pPr>
+              <a:spcAft>
+                <a:spcPts val="1200"/>
+              </a:spcAft>
+            </a:pPr>
+            <a:r>
+              <a:rPr sz="2000" b="0">
                 <a:solidFill>
                   <a:srgbClr val="10243A"/>
                 </a:solidFill>
                 <a:latin typeface="Arial"/>
               </a:rPr>
-              <a:t>PC -&gt; USB/UART COM6, 115200 8N1 -&gt; ESP32-S3.</a:t>
-            </a:r>
-          </a:p>
-        </p:txBody>
-      </p:sp>
-      <p:sp>
-        <p:nvSpPr>
-          <p:cNvPr id="9" name="TextBox 8"/>
-          <p:cNvSpPr txBox="1"/>
-          <p:nvPr/>
-        </p:nvSpPr>
-        <p:spPr>
-          <a:xfrm>
-            <a:off x="594360" y="2496312"/>
-            <a:ext cx="274320" cy="457200"/>
-          </a:xfrm>
-          <a:prstGeom prst="rect">
-            <a:avLst/>
-          </a:prstGeom>
-          <a:noFill/>
-        </p:spPr>
-        <p:txBody>
-          <a:bodyPr wrap="square" lIns="73152" rIns="73152" tIns="36576" bIns="36576">
-            <a:spAutoFit/>
-          </a:bodyPr>
-          <a:lstStyle/>
-          <a:p>
-            <a:pPr>
-              <a:spcAft>
-                <a:spcPts val="1200"/>
-              </a:spcAft>
-            </a:pPr>
-            <a:r>
-              <a:rPr sz="2200" b="1">
-                <a:solidFill>
-                  <a:srgbClr val="075985"/>
-                </a:solidFill>
-                <a:latin typeface="Arial"/>
-              </a:rPr>
-              <a:t>-</a:t>
-            </a:r>
-          </a:p>
-        </p:txBody>
-      </p:sp>
-      <p:sp>
-        <p:nvSpPr>
-          <p:cNvPr id="10" name="TextBox 9"/>
-          <p:cNvSpPr txBox="1"/>
-          <p:nvPr/>
-        </p:nvSpPr>
-        <p:spPr>
-          <a:xfrm>
-            <a:off x="914400" y="2496312"/>
-            <a:ext cx="10607040" cy="603503"/>
-          </a:xfrm>
-          <a:prstGeom prst="rect">
-            <a:avLst/>
-          </a:prstGeom>
-          <a:noFill/>
-        </p:spPr>
-        <p:txBody>
-          <a:bodyPr wrap="square" lIns="73152" rIns="73152" tIns="36576" bIns="36576">
-            <a:spAutoFit/>
-          </a:bodyPr>
-          <a:lstStyle/>
-          <a:p>
-            <a:pPr>
-              <a:spcAft>
-                <a:spcPts val="1200"/>
-              </a:spcAft>
-            </a:pPr>
-            <a:r>
-              <a:rPr sz="2200" b="0">
+              <a:t>COM6 -&gt; ESP32-S3 | sonar, relay, RGB and buttons | solid lamp, 80% brightness</a:t>
+            </a:r>
+          </a:p>
+        </p:txBody>
+      </p:sp>
+      <p:sp>
+        <p:nvSpPr>
+          <p:cNvPr id="14" name="TextBox 13"/>
+          <p:cNvSpPr txBox="1"/>
+          <p:nvPr/>
+        </p:nvSpPr>
+        <p:spPr>
+          <a:xfrm>
+            <a:off x="594360" y="5669280"/>
+            <a:ext cx="10972800" cy="548640"/>
+          </a:xfrm>
+          <a:prstGeom prst="rect">
+            <a:avLst/>
+          </a:prstGeom>
+          <a:noFill/>
+        </p:spPr>
+        <p:txBody>
+          <a:bodyPr wrap="square" lIns="73152" rIns="73152" tIns="36576" bIns="36576">
+            <a:spAutoFit/>
+          </a:bodyPr>
+          <a:lstStyle/>
+          <a:p>
+            <a:pPr>
+              <a:spcAft>
+                <a:spcPts val="1200"/>
+              </a:spcAft>
+            </a:pPr>
+            <a:r>
+              <a:rPr sz="1900" b="0">
                 <a:solidFill>
                   <a:srgbClr val="10243A"/>
                 </a:solidFill>
                 <a:latin typeface="Arial"/>
               </a:rPr>
-              <a:t>Sonar GPIO5/18 | relay GPIO8 | RGB GPIO48 | proximity LED GPIO4.</a:t>
-            </a:r>
-          </a:p>
-        </p:txBody>
-      </p:sp>
-      <p:sp>
-        <p:nvSpPr>
-          <p:cNvPr id="11" name="TextBox 10"/>
-          <p:cNvSpPr txBox="1"/>
-          <p:nvPr/>
-        </p:nvSpPr>
-        <p:spPr>
-          <a:xfrm>
-            <a:off x="594360" y="3163824"/>
-            <a:ext cx="274320" cy="457200"/>
-          </a:xfrm>
-          <a:prstGeom prst="rect">
-            <a:avLst/>
-          </a:prstGeom>
-          <a:noFill/>
-        </p:spPr>
-        <p:txBody>
-          <a:bodyPr wrap="square" lIns="73152" rIns="73152" tIns="36576" bIns="36576">
-            <a:spAutoFit/>
-          </a:bodyPr>
-          <a:lstStyle/>
-          <a:p>
-            <a:pPr>
-              <a:spcAft>
-                <a:spcPts val="1200"/>
-              </a:spcAft>
-            </a:pPr>
-            <a:r>
-              <a:rPr sz="2200" b="1">
-                <a:solidFill>
-                  <a:srgbClr val="075985"/>
-                </a:solidFill>
-                <a:latin typeface="Arial"/>
-              </a:rPr>
-              <a:t>-</a:t>
-            </a:r>
-          </a:p>
-        </p:txBody>
-      </p:sp>
-      <p:sp>
-        <p:nvSpPr>
-          <p:cNvPr id="12" name="TextBox 11"/>
-          <p:cNvSpPr txBox="1"/>
-          <p:nvPr/>
-        </p:nvSpPr>
-        <p:spPr>
-          <a:xfrm>
-            <a:off x="914400" y="3163824"/>
-            <a:ext cx="10607040" cy="603503"/>
-          </a:xfrm>
-          <a:prstGeom prst="rect">
-            <a:avLst/>
-          </a:prstGeom>
-          <a:noFill/>
-        </p:spPr>
-        <p:txBody>
-          <a:bodyPr wrap="square" lIns="73152" rIns="73152" tIns="36576" bIns="36576">
-            <a:spAutoFit/>
-          </a:bodyPr>
-          <a:lstStyle/>
-          <a:p>
-            <a:pPr>
-              <a:spcAft>
-                <a:spcPts val="1200"/>
-              </a:spcAft>
-            </a:pPr>
-            <a:r>
-              <a:rPr sz="2200" b="0">
-                <a:solidFill>
-                  <a:srgbClr val="10243A"/>
-                </a:solidFill>
-                <a:latin typeface="Arial"/>
-              </a:rPr>
-              <a:t>Buttons GPIO41/40/39/38; Wi-Fi and a local OTA fault server.</a:t>
-            </a:r>
-          </a:p>
-        </p:txBody>
-      </p:sp>
-      <p:sp>
-        <p:nvSpPr>
-          <p:cNvPr id="13" name="TextBox 12"/>
-          <p:cNvSpPr txBox="1"/>
-          <p:nvPr/>
-        </p:nvSpPr>
-        <p:spPr>
-          <a:xfrm>
-            <a:off x="594360" y="3831335"/>
-            <a:ext cx="274320" cy="457200"/>
-          </a:xfrm>
-          <a:prstGeom prst="rect">
-            <a:avLst/>
-          </a:prstGeom>
-          <a:noFill/>
-        </p:spPr>
-        <p:txBody>
-          <a:bodyPr wrap="square" lIns="73152" rIns="73152" tIns="36576" bIns="36576">
-            <a:spAutoFit/>
-          </a:bodyPr>
-          <a:lstStyle/>
-          <a:p>
-            <a:pPr>
-              <a:spcAft>
-                <a:spcPts val="1200"/>
-              </a:spcAft>
-            </a:pPr>
-            <a:r>
-              <a:rPr sz="2200" b="1">
-                <a:solidFill>
-                  <a:srgbClr val="075985"/>
-                </a:solidFill>
-                <a:latin typeface="Arial"/>
-              </a:rPr>
-              <a:t>-</a:t>
-            </a:r>
-          </a:p>
-        </p:txBody>
-      </p:sp>
-      <p:sp>
-        <p:nvSpPr>
-          <p:cNvPr id="14" name="TextBox 13"/>
-          <p:cNvSpPr txBox="1"/>
-          <p:nvPr/>
-        </p:nvSpPr>
-        <p:spPr>
-          <a:xfrm>
-            <a:off x="914400" y="3831335"/>
-            <a:ext cx="10607040" cy="603503"/>
-          </a:xfrm>
-          <a:prstGeom prst="rect">
-            <a:avLst/>
-          </a:prstGeom>
-          <a:noFill/>
-        </p:spPr>
-        <p:txBody>
-          <a:bodyPr wrap="square" lIns="73152" rIns="73152" tIns="36576" bIns="36576">
-            <a:spAutoFit/>
-          </a:bodyPr>
-          <a:lstStyle/>
-          <a:p>
-            <a:pPr>
-              <a:spcAft>
-                <a:spcPts val="1200"/>
-              </a:spcAft>
-            </a:pPr>
-            <a:r>
-              <a:rPr sz="2200" b="0">
-                <a:solidFill>
-                  <a:srgbClr val="10243A"/>
-                </a:solidFill>
-                <a:latin typeface="Arial"/>
-              </a:rPr>
-              <a:t>Observed: RGB colours, relay clicks, all state chords and Guard alarms.</a:t>
-            </a:r>
-          </a:p>
-        </p:txBody>
-      </p:sp>
-      <p:sp>
-        <p:nvSpPr>
-          <p:cNvPr id="15" name="TextBox 14"/>
-          <p:cNvSpPr txBox="1"/>
-          <p:nvPr/>
-        </p:nvSpPr>
-        <p:spPr>
-          <a:xfrm>
-            <a:off x="594360" y="4498848"/>
-            <a:ext cx="274320" cy="457200"/>
-          </a:xfrm>
-          <a:prstGeom prst="rect">
-            <a:avLst/>
-          </a:prstGeom>
-          <a:noFill/>
-        </p:spPr>
-        <p:txBody>
-          <a:bodyPr wrap="square" lIns="73152" rIns="73152" tIns="36576" bIns="36576">
-            <a:spAutoFit/>
-          </a:bodyPr>
-          <a:lstStyle/>
-          <a:p>
-            <a:pPr>
-              <a:spcAft>
-                <a:spcPts val="1200"/>
-              </a:spcAft>
-            </a:pPr>
-            <a:r>
-              <a:rPr sz="2200" b="1">
-                <a:solidFill>
-                  <a:srgbClr val="075985"/>
-                </a:solidFill>
-                <a:latin typeface="Arial"/>
-              </a:rPr>
-              <a:t>-</a:t>
-            </a:r>
-          </a:p>
-        </p:txBody>
-      </p:sp>
-      <p:sp>
-        <p:nvSpPr>
-          <p:cNvPr id="16" name="TextBox 15"/>
-          <p:cNvSpPr txBox="1"/>
-          <p:nvPr/>
-        </p:nvSpPr>
-        <p:spPr>
-          <a:xfrm>
-            <a:off x="914400" y="4498848"/>
-            <a:ext cx="10607040" cy="603503"/>
-          </a:xfrm>
-          <a:prstGeom prst="rect">
-            <a:avLst/>
-          </a:prstGeom>
-          <a:noFill/>
-        </p:spPr>
-        <p:txBody>
-          <a:bodyPr wrap="square" lIns="73152" rIns="73152" tIns="36576" bIns="36576">
-            <a:spAutoFit/>
-          </a:bodyPr>
-          <a:lstStyle/>
-          <a:p>
-            <a:pPr>
-              <a:spcAft>
-                <a:spcPts val="1200"/>
-              </a:spcAft>
-            </a:pPr>
-            <a:r>
-              <a:rPr sz="2200" b="0">
-                <a:solidFill>
-                  <a:srgbClr val="10243A"/>
-                </a:solidFill>
-                <a:latin typeface="Arial"/>
-              </a:rPr>
-              <a:t>Ruler targets at 10/20/30/50 cm; 20 cm calibration checked on both builds.</a:t>
-            </a:r>
-          </a:p>
-        </p:txBody>
-      </p:sp>
-      <p:sp>
-        <p:nvSpPr>
-          <p:cNvPr id="17" name="TextBox 16"/>
-          <p:cNvSpPr txBox="1"/>
-          <p:nvPr/>
-        </p:nvSpPr>
-        <p:spPr>
-          <a:xfrm>
-            <a:off x="594360" y="5166360"/>
-            <a:ext cx="274320" cy="457200"/>
-          </a:xfrm>
-          <a:prstGeom prst="rect">
-            <a:avLst/>
-          </a:prstGeom>
-          <a:noFill/>
-        </p:spPr>
-        <p:txBody>
-          <a:bodyPr wrap="square" lIns="73152" rIns="73152" tIns="36576" bIns="36576">
-            <a:spAutoFit/>
-          </a:bodyPr>
-          <a:lstStyle/>
-          <a:p>
-            <a:pPr>
-              <a:spcAft>
-                <a:spcPts val="1200"/>
-              </a:spcAft>
-            </a:pPr>
-            <a:r>
-              <a:rPr sz="2200" b="1">
-                <a:solidFill>
-                  <a:srgbClr val="075985"/>
-                </a:solidFill>
-                <a:latin typeface="Arial"/>
-              </a:rPr>
-              <a:t>-</a:t>
-            </a:r>
-          </a:p>
-        </p:txBody>
-      </p:sp>
-      <p:sp>
-        <p:nvSpPr>
-          <p:cNvPr id="18" name="TextBox 17"/>
-          <p:cNvSpPr txBox="1"/>
-          <p:nvPr/>
-        </p:nvSpPr>
-        <p:spPr>
-          <a:xfrm>
-            <a:off x="914400" y="5166360"/>
-            <a:ext cx="10607040" cy="603503"/>
-          </a:xfrm>
-          <a:prstGeom prst="rect">
-            <a:avLst/>
-          </a:prstGeom>
-          <a:noFill/>
-        </p:spPr>
-        <p:txBody>
-          <a:bodyPr wrap="square" lIns="73152" rIns="73152" tIns="36576" bIns="36576">
-            <a:spAutoFit/>
-          </a:bodyPr>
-          <a:lstStyle/>
-          <a:p>
-            <a:pPr>
-              <a:spcAft>
-                <a:spcPts val="1200"/>
-              </a:spcAft>
-            </a:pPr>
-            <a:r>
-              <a:rPr sz="2200" b="0">
-                <a:solidFill>
-                  <a:srgbClr val="10243A"/>
-                </a:solidFill>
-                <a:latin typeface="Arial"/>
-              </a:rPr>
-              <a:t>Low voltage, relay unloaded: no mains, no contact/load verification.</a:t>
+              <a:t>Tester confirmed each colour; bright cores are overexposed. Low voltage, relay unloaded.</a:t>
             </a:r>
           </a:p>
         </p:txBody>
@@ -6148,53 +6585,537 @@
       </p:sp>
       <p:sp>
         <p:nvSpPr>
-          <p:cNvPr id="7" name="TextBox 6"/>
-          <p:cNvSpPr txBox="1"/>
-          <p:nvPr/>
-        </p:nvSpPr>
-        <p:spPr>
-          <a:xfrm>
-            <a:off x="594360" y="1828800"/>
-            <a:ext cx="274320" cy="457200"/>
-          </a:xfrm>
-          <a:prstGeom prst="rect">
-            <a:avLst/>
-          </a:prstGeom>
-          <a:noFill/>
-        </p:spPr>
-        <p:txBody>
-          <a:bodyPr wrap="square" lIns="73152" rIns="73152" tIns="36576" bIns="36576">
-            <a:spAutoFit/>
-          </a:bodyPr>
-          <a:lstStyle/>
-          <a:p>
-            <a:pPr>
-              <a:spcAft>
-                <a:spcPts val="1200"/>
-              </a:spcAft>
-            </a:pPr>
-            <a:r>
-              <a:rPr sz="2200" b="1">
+          <p:cNvPr id="7" name="Rounded Rectangle 6"/>
+          <p:cNvSpPr/>
+          <p:nvPr/>
+        </p:nvSpPr>
+        <p:spPr>
+          <a:xfrm>
+            <a:off x="594360" y="1874519"/>
+            <a:ext cx="3291840" cy="1234440"/>
+          </a:xfrm>
+          <a:prstGeom prst="roundRect">
+            <a:avLst/>
+          </a:prstGeom>
+          <a:solidFill>
+            <a:srgbClr val="E8F1F7"/>
+          </a:solidFill>
+          <a:ln>
+            <a:noFill/>
+          </a:ln>
+        </p:spPr>
+        <p:style>
+          <a:lnRef idx="1">
+            <a:schemeClr val="accent1"/>
+          </a:lnRef>
+          <a:fillRef idx="3">
+            <a:schemeClr val="accent1"/>
+          </a:fillRef>
+          <a:effectRef idx="2">
+            <a:schemeClr val="accent1"/>
+          </a:effectRef>
+          <a:fontRef idx="minor">
+            <a:schemeClr val="lt1"/>
+          </a:fontRef>
+        </p:style>
+        <p:txBody>
+          <a:bodyPr rtlCol="0" anchor="ctr"/>
+          <a:lstStyle/>
+          <a:p>
+            <a:pPr algn="ctr"/>
+          </a:p>
+        </p:txBody>
+      </p:sp>
+      <p:sp>
+        <p:nvSpPr>
+          <p:cNvPr id="8" name="TextBox 7"/>
+          <p:cNvSpPr txBox="1"/>
+          <p:nvPr/>
+        </p:nvSpPr>
+        <p:spPr>
+          <a:xfrm>
+            <a:off x="704088" y="1993392"/>
+            <a:ext cx="3063240" cy="411480"/>
+          </a:xfrm>
+          <a:prstGeom prst="rect">
+            <a:avLst/>
+          </a:prstGeom>
+          <a:noFill/>
+        </p:spPr>
+        <p:txBody>
+          <a:bodyPr wrap="square" lIns="73152" rIns="73152" tIns="36576" bIns="36576">
+            <a:spAutoFit/>
+          </a:bodyPr>
+          <a:lstStyle/>
+          <a:p>
+            <a:pPr>
+              <a:spcAft>
+                <a:spcPts val="1200"/>
+              </a:spcAft>
+            </a:pPr>
+            <a:r>
+              <a:rPr sz="2300" b="1">
                 <a:solidFill>
                   <a:srgbClr val="075985"/>
                 </a:solidFill>
                 <a:latin typeface="Arial"/>
               </a:rPr>
-              <a:t>-</a:t>
-            </a:r>
-          </a:p>
-        </p:txBody>
-      </p:sp>
-      <p:sp>
-        <p:nvSpPr>
-          <p:cNvPr id="8" name="TextBox 7"/>
-          <p:cNvSpPr txBox="1"/>
-          <p:nvPr/>
-        </p:nvSpPr>
-        <p:spPr>
-          <a:xfrm>
-            <a:off x="914400" y="1828800"/>
-            <a:ext cx="10607040" cy="603503"/>
+              <a:t>STABLE 2.1.0</a:t>
+            </a:r>
+          </a:p>
+        </p:txBody>
+      </p:sp>
+      <p:sp>
+        <p:nvSpPr>
+          <p:cNvPr id="9" name="TextBox 8"/>
+          <p:cNvSpPr txBox="1"/>
+          <p:nvPr/>
+        </p:nvSpPr>
+        <p:spPr>
+          <a:xfrm>
+            <a:off x="704088" y="2514600"/>
+            <a:ext cx="3063240" cy="411480"/>
+          </a:xfrm>
+          <a:prstGeom prst="rect">
+            <a:avLst/>
+          </a:prstGeom>
+          <a:noFill/>
+        </p:spPr>
+        <p:txBody>
+          <a:bodyPr wrap="square" lIns="73152" rIns="73152" tIns="36576" bIns="36576">
+            <a:spAutoFit/>
+          </a:bodyPr>
+          <a:lstStyle/>
+          <a:p>
+            <a:pPr>
+              <a:spcAft>
+                <a:spcPts val="1200"/>
+              </a:spcAft>
+            </a:pPr>
+            <a:r>
+              <a:rPr sz="1800" b="0">
+                <a:solidFill>
+                  <a:srgbClr val="10243A"/>
+                </a:solidFill>
+                <a:latin typeface="Arial"/>
+              </a:rPr>
+              <a:t>Known baseline</a:t>
+            </a:r>
+          </a:p>
+        </p:txBody>
+      </p:sp>
+      <p:sp>
+        <p:nvSpPr>
+          <p:cNvPr id="10" name="Rounded Rectangle 9"/>
+          <p:cNvSpPr/>
+          <p:nvPr/>
+        </p:nvSpPr>
+        <p:spPr>
+          <a:xfrm>
+            <a:off x="4434840" y="1874519"/>
+            <a:ext cx="3291840" cy="1234440"/>
+          </a:xfrm>
+          <a:prstGeom prst="roundRect">
+            <a:avLst/>
+          </a:prstGeom>
+          <a:solidFill>
+            <a:srgbClr val="E8F1F7"/>
+          </a:solidFill>
+          <a:ln>
+            <a:noFill/>
+          </a:ln>
+        </p:spPr>
+        <p:style>
+          <a:lnRef idx="1">
+            <a:schemeClr val="accent1"/>
+          </a:lnRef>
+          <a:fillRef idx="3">
+            <a:schemeClr val="accent1"/>
+          </a:fillRef>
+          <a:effectRef idx="2">
+            <a:schemeClr val="accent1"/>
+          </a:effectRef>
+          <a:fontRef idx="minor">
+            <a:schemeClr val="lt1"/>
+          </a:fontRef>
+        </p:style>
+        <p:txBody>
+          <a:bodyPr rtlCol="0" anchor="ctr"/>
+          <a:lstStyle/>
+          <a:p>
+            <a:pPr algn="ctr"/>
+          </a:p>
+        </p:txBody>
+      </p:sp>
+      <p:sp>
+        <p:nvSpPr>
+          <p:cNvPr id="11" name="TextBox 10"/>
+          <p:cNvSpPr txBox="1"/>
+          <p:nvPr/>
+        </p:nvSpPr>
+        <p:spPr>
+          <a:xfrm>
+            <a:off x="4544568" y="1993392"/>
+            <a:ext cx="3063240" cy="411480"/>
+          </a:xfrm>
+          <a:prstGeom prst="rect">
+            <a:avLst/>
+          </a:prstGeom>
+          <a:noFill/>
+        </p:spPr>
+        <p:txBody>
+          <a:bodyPr wrap="square" lIns="73152" rIns="73152" tIns="36576" bIns="36576">
+            <a:spAutoFit/>
+          </a:bodyPr>
+          <a:lstStyle/>
+          <a:p>
+            <a:pPr>
+              <a:spcAft>
+                <a:spcPts val="1200"/>
+              </a:spcAft>
+            </a:pPr>
+            <a:r>
+              <a:rPr sz="2300" b="1">
+                <a:solidFill>
+                  <a:srgbClr val="075985"/>
+                </a:solidFill>
+                <a:latin typeface="Arial"/>
+              </a:rPr>
+              <a:t>UPDATE + CHECK</a:t>
+            </a:r>
+          </a:p>
+        </p:txBody>
+      </p:sp>
+      <p:sp>
+        <p:nvSpPr>
+          <p:cNvPr id="12" name="TextBox 11"/>
+          <p:cNvSpPr txBox="1"/>
+          <p:nvPr/>
+        </p:nvSpPr>
+        <p:spPr>
+          <a:xfrm>
+            <a:off x="4544568" y="2514600"/>
+            <a:ext cx="3063240" cy="411480"/>
+          </a:xfrm>
+          <a:prstGeom prst="rect">
+            <a:avLst/>
+          </a:prstGeom>
+          <a:noFill/>
+        </p:spPr>
+        <p:txBody>
+          <a:bodyPr wrap="square" lIns="73152" rIns="73152" tIns="36576" bIns="36576">
+            <a:spAutoFit/>
+          </a:bodyPr>
+          <a:lstStyle/>
+          <a:p>
+            <a:pPr>
+              <a:spcAft>
+                <a:spcPts val="1200"/>
+              </a:spcAft>
+            </a:pPr>
+            <a:r>
+              <a:rPr sz="1800" b="0">
+                <a:solidFill>
+                  <a:srgbClr val="10243A"/>
+                </a:solidFill>
+                <a:latin typeface="Arial"/>
+              </a:rPr>
+              <a:t>Download / boot / validate</a:t>
+            </a:r>
+          </a:p>
+        </p:txBody>
+      </p:sp>
+      <p:sp>
+        <p:nvSpPr>
+          <p:cNvPr id="13" name="Rounded Rectangle 12"/>
+          <p:cNvSpPr/>
+          <p:nvPr/>
+        </p:nvSpPr>
+        <p:spPr>
+          <a:xfrm>
+            <a:off x="8275320" y="1874519"/>
+            <a:ext cx="3291840" cy="1234440"/>
+          </a:xfrm>
+          <a:prstGeom prst="roundRect">
+            <a:avLst/>
+          </a:prstGeom>
+          <a:solidFill>
+            <a:srgbClr val="E8F1F7"/>
+          </a:solidFill>
+          <a:ln>
+            <a:noFill/>
+          </a:ln>
+        </p:spPr>
+        <p:style>
+          <a:lnRef idx="1">
+            <a:schemeClr val="accent1"/>
+          </a:lnRef>
+          <a:fillRef idx="3">
+            <a:schemeClr val="accent1"/>
+          </a:fillRef>
+          <a:effectRef idx="2">
+            <a:schemeClr val="accent1"/>
+          </a:effectRef>
+          <a:fontRef idx="minor">
+            <a:schemeClr val="lt1"/>
+          </a:fontRef>
+        </p:style>
+        <p:txBody>
+          <a:bodyPr rtlCol="0" anchor="ctr"/>
+          <a:lstStyle/>
+          <a:p>
+            <a:pPr algn="ctr"/>
+          </a:p>
+        </p:txBody>
+      </p:sp>
+      <p:sp>
+        <p:nvSpPr>
+          <p:cNvPr id="14" name="TextBox 13"/>
+          <p:cNvSpPr txBox="1"/>
+          <p:nvPr/>
+        </p:nvSpPr>
+        <p:spPr>
+          <a:xfrm>
+            <a:off x="8385048" y="1993392"/>
+            <a:ext cx="3063240" cy="411480"/>
+          </a:xfrm>
+          <a:prstGeom prst="rect">
+            <a:avLst/>
+          </a:prstGeom>
+          <a:noFill/>
+        </p:spPr>
+        <p:txBody>
+          <a:bodyPr wrap="square" lIns="73152" rIns="73152" tIns="36576" bIns="36576">
+            <a:spAutoFit/>
+          </a:bodyPr>
+          <a:lstStyle/>
+          <a:p>
+            <a:pPr>
+              <a:spcAft>
+                <a:spcPts val="1200"/>
+              </a:spcAft>
+            </a:pPr>
+            <a:r>
+              <a:rPr sz="2300" b="1">
+                <a:solidFill>
+                  <a:srgbClr val="075985"/>
+                </a:solidFill>
+                <a:latin typeface="Arial"/>
+              </a:rPr>
+              <a:t>BETA 2.3.0</a:t>
+            </a:r>
+          </a:p>
+        </p:txBody>
+      </p:sp>
+      <p:sp>
+        <p:nvSpPr>
+          <p:cNvPr id="15" name="TextBox 14"/>
+          <p:cNvSpPr txBox="1"/>
+          <p:nvPr/>
+        </p:nvSpPr>
+        <p:spPr>
+          <a:xfrm>
+            <a:off x="8385048" y="2514600"/>
+            <a:ext cx="3063240" cy="411480"/>
+          </a:xfrm>
+          <a:prstGeom prst="rect">
+            <a:avLst/>
+          </a:prstGeom>
+          <a:noFill/>
+        </p:spPr>
+        <p:txBody>
+          <a:bodyPr wrap="square" lIns="73152" rIns="73152" tIns="36576" bIns="36576">
+            <a:spAutoFit/>
+          </a:bodyPr>
+          <a:lstStyle/>
+          <a:p>
+            <a:pPr>
+              <a:spcAft>
+                <a:spcPts val="1200"/>
+              </a:spcAft>
+            </a:pPr>
+            <a:r>
+              <a:rPr sz="1800" b="0">
+                <a:solidFill>
+                  <a:srgbClr val="10243A"/>
+                </a:solidFill>
+                <a:latin typeface="Arial"/>
+              </a:rPr>
+              <a:t>Valid running image</a:t>
+            </a:r>
+          </a:p>
+        </p:txBody>
+      </p:sp>
+      <p:sp>
+        <p:nvSpPr>
+          <p:cNvPr id="16" name="TextBox 15"/>
+          <p:cNvSpPr txBox="1"/>
+          <p:nvPr/>
+        </p:nvSpPr>
+        <p:spPr>
+          <a:xfrm>
+            <a:off x="3931920" y="2240280"/>
+            <a:ext cx="502920" cy="457200"/>
+          </a:xfrm>
+          <a:prstGeom prst="rect">
+            <a:avLst/>
+          </a:prstGeom>
+          <a:noFill/>
+        </p:spPr>
+        <p:txBody>
+          <a:bodyPr wrap="square" lIns="73152" rIns="73152" tIns="36576" bIns="36576">
+            <a:spAutoFit/>
+          </a:bodyPr>
+          <a:lstStyle/>
+          <a:p>
+            <a:pPr>
+              <a:spcAft>
+                <a:spcPts val="1200"/>
+              </a:spcAft>
+            </a:pPr>
+            <a:r>
+              <a:rPr sz="2800" b="1">
+                <a:solidFill>
+                  <a:srgbClr val="075985"/>
+                </a:solidFill>
+                <a:latin typeface="Arial"/>
+              </a:rPr>
+              <a:t>&gt;</a:t>
+            </a:r>
+          </a:p>
+        </p:txBody>
+      </p:sp>
+      <p:sp>
+        <p:nvSpPr>
+          <p:cNvPr id="17" name="TextBox 16"/>
+          <p:cNvSpPr txBox="1"/>
+          <p:nvPr/>
+        </p:nvSpPr>
+        <p:spPr>
+          <a:xfrm>
+            <a:off x="7772400" y="2240280"/>
+            <a:ext cx="502920" cy="457200"/>
+          </a:xfrm>
+          <a:prstGeom prst="rect">
+            <a:avLst/>
+          </a:prstGeom>
+          <a:noFill/>
+        </p:spPr>
+        <p:txBody>
+          <a:bodyPr wrap="square" lIns="73152" rIns="73152" tIns="36576" bIns="36576">
+            <a:spAutoFit/>
+          </a:bodyPr>
+          <a:lstStyle/>
+          <a:p>
+            <a:pPr>
+              <a:spcAft>
+                <a:spcPts val="1200"/>
+              </a:spcAft>
+            </a:pPr>
+            <a:r>
+              <a:rPr sz="2800" b="1">
+                <a:solidFill>
+                  <a:srgbClr val="075985"/>
+                </a:solidFill>
+                <a:latin typeface="Arial"/>
+              </a:rPr>
+              <a:t>&gt;</a:t>
+            </a:r>
+          </a:p>
+        </p:txBody>
+      </p:sp>
+      <p:sp>
+        <p:nvSpPr>
+          <p:cNvPr id="18" name="Rounded Rectangle 17"/>
+          <p:cNvSpPr/>
+          <p:nvPr/>
+        </p:nvSpPr>
+        <p:spPr>
+          <a:xfrm>
+            <a:off x="594360" y="3429000"/>
+            <a:ext cx="10972800" cy="777240"/>
+          </a:xfrm>
+          <a:prstGeom prst="roundRect">
+            <a:avLst/>
+          </a:prstGeom>
+          <a:solidFill>
+            <a:srgbClr val="E8F1F7"/>
+          </a:solidFill>
+          <a:ln>
+            <a:noFill/>
+          </a:ln>
+        </p:spPr>
+        <p:style>
+          <a:lnRef idx="1">
+            <a:schemeClr val="accent1"/>
+          </a:lnRef>
+          <a:fillRef idx="3">
+            <a:schemeClr val="accent1"/>
+          </a:fillRef>
+          <a:effectRef idx="2">
+            <a:schemeClr val="accent1"/>
+          </a:effectRef>
+          <a:fontRef idx="minor">
+            <a:schemeClr val="lt1"/>
+          </a:fontRef>
+        </p:style>
+        <p:txBody>
+          <a:bodyPr rtlCol="0" anchor="ctr"/>
+          <a:lstStyle/>
+          <a:p>
+            <a:pPr algn="ctr"/>
+          </a:p>
+        </p:txBody>
+      </p:sp>
+      <p:sp>
+        <p:nvSpPr>
+          <p:cNvPr id="19" name="TextBox 18"/>
+          <p:cNvSpPr txBox="1"/>
+          <p:nvPr/>
+        </p:nvSpPr>
+        <p:spPr>
+          <a:xfrm>
+            <a:off x="777240" y="3566160"/>
+            <a:ext cx="10607040" cy="502920"/>
+          </a:xfrm>
+          <a:prstGeom prst="rect">
+            <a:avLst/>
+          </a:prstGeom>
+          <a:noFill/>
+        </p:spPr>
+        <p:txBody>
+          <a:bodyPr wrap="square" lIns="73152" rIns="73152" tIns="36576" bIns="36576">
+            <a:spAutoFit/>
+          </a:bodyPr>
+          <a:lstStyle/>
+          <a:p>
+            <a:pPr>
+              <a:spcAft>
+                <a:spcPts val="1200"/>
+              </a:spcAft>
+            </a:pPr>
+            <a:r>
+              <a:rPr sz="2300" b="1">
+                <a:solidFill>
+                  <a:srgbClr val="991B1B"/>
+                </a:solidFill>
+                <a:latin typeface="Arial"/>
+              </a:rPr>
+              <a:t>Broken image -&gt; self-check failure -&gt; automatic rollback -&gt; usable firmware</a:t>
+            </a:r>
+          </a:p>
+        </p:txBody>
+      </p:sp>
+      <p:sp>
+        <p:nvSpPr>
+          <p:cNvPr id="20" name="TextBox 19"/>
+          <p:cNvSpPr txBox="1"/>
+          <p:nvPr/>
+        </p:nvSpPr>
+        <p:spPr>
+          <a:xfrm>
+            <a:off x="594360" y="4526280"/>
+            <a:ext cx="10972800" cy="1005840"/>
           </a:xfrm>
           <a:prstGeom prst="rect">
             <a:avLst/>
@@ -6219,71 +7140,9 @@
                 </a:solidFill>
                 <a:latin typeface="Arial"/>
               </a:rPr>
-              <a:t>Upgrade 2.1.0 -&gt; 2.3.0: boot and self-check passed.</a:t>
-            </a:r>
-          </a:p>
-        </p:txBody>
-      </p:sp>
-      <p:sp>
-        <p:nvSpPr>
-          <p:cNvPr id="9" name="TextBox 8"/>
-          <p:cNvSpPr txBox="1"/>
-          <p:nvPr/>
-        </p:nvSpPr>
-        <p:spPr>
-          <a:xfrm>
-            <a:off x="594360" y="2496312"/>
-            <a:ext cx="274320" cy="457200"/>
-          </a:xfrm>
-          <a:prstGeom prst="rect">
-            <a:avLst/>
-          </a:prstGeom>
-          <a:noFill/>
-        </p:spPr>
-        <p:txBody>
-          <a:bodyPr wrap="square" lIns="73152" rIns="73152" tIns="36576" bIns="36576">
-            <a:spAutoFit/>
-          </a:bodyPr>
-          <a:lstStyle/>
-          <a:p>
-            <a:pPr>
-              <a:spcAft>
-                <a:spcPts val="1200"/>
-              </a:spcAft>
-            </a:pPr>
-            <a:r>
-              <a:rPr sz="2200" b="1">
-                <a:solidFill>
-                  <a:srgbClr val="075985"/>
-                </a:solidFill>
-                <a:latin typeface="Arial"/>
-              </a:rPr>
-              <a:t>-</a:t>
-            </a:r>
-          </a:p>
-        </p:txBody>
-      </p:sp>
-      <p:sp>
-        <p:nvSpPr>
-          <p:cNvPr id="10" name="TextBox 9"/>
-          <p:cNvSpPr txBox="1"/>
-          <p:nvPr/>
-        </p:nvSpPr>
-        <p:spPr>
-          <a:xfrm>
-            <a:off x="914400" y="2496312"/>
-            <a:ext cx="10607040" cy="603503"/>
-          </a:xfrm>
-          <a:prstGeom prst="rect">
-            <a:avLst/>
-          </a:prstGeom>
-          <a:noFill/>
-        </p:spPr>
-        <p:txBody>
-          <a:bodyPr wrap="square" lIns="73152" rIns="73152" tIns="36576" bIns="36576">
-            <a:spAutoFit/>
-          </a:bodyPr>
-          <a:lstStyle/>
+              <a:t>Both builds: garbage, truncated, corrupted and interrupted-image tests.</a:t>
+            </a:r>
+          </a:p>
           <a:p>
             <a:pPr>
               <a:spcAft>
@@ -6297,319 +7156,46 @@
                 </a:solidFill>
                 <a:latin typeface="Arial"/>
               </a:rPr>
-              <a:t>Broken image: self-check failed; automatic rollback observed.</a:t>
-            </a:r>
-          </a:p>
-        </p:txBody>
-      </p:sp>
-      <p:sp>
-        <p:nvSpPr>
-          <p:cNvPr id="11" name="TextBox 10"/>
-          <p:cNvSpPr txBox="1"/>
-          <p:nvPr/>
-        </p:nvSpPr>
-        <p:spPr>
-          <a:xfrm>
-            <a:off x="594360" y="3163824"/>
-            <a:ext cx="274320" cy="457200"/>
-          </a:xfrm>
-          <a:prstGeom prst="rect">
-            <a:avLst/>
-          </a:prstGeom>
-          <a:noFill/>
-        </p:spPr>
-        <p:txBody>
-          <a:bodyPr wrap="square" lIns="73152" rIns="73152" tIns="36576" bIns="36576">
-            <a:spAutoFit/>
-          </a:bodyPr>
-          <a:lstStyle/>
-          <a:p>
-            <a:pPr>
-              <a:spcAft>
-                <a:spcPts val="1200"/>
-              </a:spcAft>
-            </a:pPr>
-            <a:r>
-              <a:rPr sz="2200" b="1">
-                <a:solidFill>
-                  <a:srgbClr val="075985"/>
-                </a:solidFill>
-                <a:latin typeface="Arial"/>
-              </a:rPr>
-              <a:t>-</a:t>
-            </a:r>
-          </a:p>
-        </p:txBody>
-      </p:sp>
-      <p:sp>
-        <p:nvSpPr>
-          <p:cNvPr id="12" name="TextBox 11"/>
-          <p:cNvSpPr txBox="1"/>
-          <p:nvPr/>
-        </p:nvSpPr>
-        <p:spPr>
-          <a:xfrm>
-            <a:off x="914400" y="3163824"/>
-            <a:ext cx="10607040" cy="603503"/>
-          </a:xfrm>
-          <a:prstGeom prst="rect">
-            <a:avLst/>
-          </a:prstGeom>
-          <a:noFill/>
-        </p:spPr>
-        <p:txBody>
-          <a:bodyPr wrap="square" lIns="73152" rIns="73152" tIns="36576" bIns="36576">
-            <a:spAutoFit/>
-          </a:bodyPr>
-          <a:lstStyle/>
-          <a:p>
-            <a:pPr>
-              <a:spcAft>
-                <a:spcPts val="1200"/>
-              </a:spcAft>
-            </a:pPr>
-            <a:r>
-              <a:rPr sz="2200" b="0">
+              <a:t>Manual rollback both ways; downgrade, URL, server and channel checks.</a:t>
+            </a:r>
+          </a:p>
+        </p:txBody>
+      </p:sp>
+      <p:sp>
+        <p:nvSpPr>
+          <p:cNvPr id="21" name="TextBox 20"/>
+          <p:cNvSpPr txBox="1"/>
+          <p:nvPr/>
+        </p:nvSpPr>
+        <p:spPr>
+          <a:xfrm>
+            <a:off x="594360" y="5669280"/>
+            <a:ext cx="10972800" cy="457200"/>
+          </a:xfrm>
+          <a:prstGeom prst="rect">
+            <a:avLst/>
+          </a:prstGeom>
+          <a:noFill/>
+        </p:spPr>
+        <p:txBody>
+          <a:bodyPr wrap="square" lIns="73152" rIns="73152" tIns="36576" bIns="36576">
+            <a:spAutoFit/>
+          </a:bodyPr>
+          <a:lstStyle/>
+          <a:p>
+            <a:pPr>
+              <a:spcAft>
+                <a:spcPts val="1200"/>
+              </a:spcAft>
+            </a:pPr>
+            <a:r>
+              <a:rPr sz="2000" b="0">
                 <a:solidFill>
                   <a:srgbClr val="10243A"/>
                 </a:solidFill>
                 <a:latin typeface="Arial"/>
               </a:rPr>
-              <a:t>Manual rollback tested both ways; stable fallback restored and verified.</a:t>
-            </a:r>
-          </a:p>
-        </p:txBody>
-      </p:sp>
-      <p:sp>
-        <p:nvSpPr>
-          <p:cNvPr id="13" name="TextBox 12"/>
-          <p:cNvSpPr txBox="1"/>
-          <p:nvPr/>
-        </p:nvSpPr>
-        <p:spPr>
-          <a:xfrm>
-            <a:off x="594360" y="3831335"/>
-            <a:ext cx="274320" cy="457200"/>
-          </a:xfrm>
-          <a:prstGeom prst="rect">
-            <a:avLst/>
-          </a:prstGeom>
-          <a:noFill/>
-        </p:spPr>
-        <p:txBody>
-          <a:bodyPr wrap="square" lIns="73152" rIns="73152" tIns="36576" bIns="36576">
-            <a:spAutoFit/>
-          </a:bodyPr>
-          <a:lstStyle/>
-          <a:p>
-            <a:pPr>
-              <a:spcAft>
-                <a:spcPts val="1200"/>
-              </a:spcAft>
-            </a:pPr>
-            <a:r>
-              <a:rPr sz="2200" b="1">
-                <a:solidFill>
-                  <a:srgbClr val="075985"/>
-                </a:solidFill>
-                <a:latin typeface="Arial"/>
-              </a:rPr>
-              <a:t>-</a:t>
-            </a:r>
-          </a:p>
-        </p:txBody>
-      </p:sp>
-      <p:sp>
-        <p:nvSpPr>
-          <p:cNvPr id="14" name="TextBox 13"/>
-          <p:cNvSpPr txBox="1"/>
-          <p:nvPr/>
-        </p:nvSpPr>
-        <p:spPr>
-          <a:xfrm>
-            <a:off x="914400" y="3831335"/>
-            <a:ext cx="10607040" cy="603503"/>
-          </a:xfrm>
-          <a:prstGeom prst="rect">
-            <a:avLst/>
-          </a:prstGeom>
-          <a:noFill/>
-        </p:spPr>
-        <p:txBody>
-          <a:bodyPr wrap="square" lIns="73152" rIns="73152" tIns="36576" bIns="36576">
-            <a:spAutoFit/>
-          </a:bodyPr>
-          <a:lstStyle/>
-          <a:p>
-            <a:pPr>
-              <a:spcAft>
-                <a:spcPts val="1200"/>
-              </a:spcAft>
-            </a:pPr>
-            <a:r>
-              <a:rPr sz="2200" b="0">
-                <a:solidFill>
-                  <a:srgbClr val="10243A"/>
-                </a:solidFill>
-                <a:latin typeface="Arial"/>
-              </a:rPr>
-              <a:t>Both builds: garbage, truncated, corrupted and interrupted-image tests.</a:t>
-            </a:r>
-          </a:p>
-        </p:txBody>
-      </p:sp>
-      <p:sp>
-        <p:nvSpPr>
-          <p:cNvPr id="15" name="TextBox 14"/>
-          <p:cNvSpPr txBox="1"/>
-          <p:nvPr/>
-        </p:nvSpPr>
-        <p:spPr>
-          <a:xfrm>
-            <a:off x="594360" y="4498848"/>
-            <a:ext cx="274320" cy="457200"/>
-          </a:xfrm>
-          <a:prstGeom prst="rect">
-            <a:avLst/>
-          </a:prstGeom>
-          <a:noFill/>
-        </p:spPr>
-        <p:txBody>
-          <a:bodyPr wrap="square" lIns="73152" rIns="73152" tIns="36576" bIns="36576">
-            <a:spAutoFit/>
-          </a:bodyPr>
-          <a:lstStyle/>
-          <a:p>
-            <a:pPr>
-              <a:spcAft>
-                <a:spcPts val="1200"/>
-              </a:spcAft>
-            </a:pPr>
-            <a:r>
-              <a:rPr sz="2200" b="1">
-                <a:solidFill>
-                  <a:srgbClr val="075985"/>
-                </a:solidFill>
-                <a:latin typeface="Arial"/>
-              </a:rPr>
-              <a:t>-</a:t>
-            </a:r>
-          </a:p>
-        </p:txBody>
-      </p:sp>
-      <p:sp>
-        <p:nvSpPr>
-          <p:cNvPr id="16" name="TextBox 15"/>
-          <p:cNvSpPr txBox="1"/>
-          <p:nvPr/>
-        </p:nvSpPr>
-        <p:spPr>
-          <a:xfrm>
-            <a:off x="914400" y="4498848"/>
-            <a:ext cx="10607040" cy="603503"/>
-          </a:xfrm>
-          <a:prstGeom prst="rect">
-            <a:avLst/>
-          </a:prstGeom>
-          <a:noFill/>
-        </p:spPr>
-        <p:txBody>
-          <a:bodyPr wrap="square" lIns="73152" rIns="73152" tIns="36576" bIns="36576">
-            <a:spAutoFit/>
-          </a:bodyPr>
-          <a:lstStyle/>
-          <a:p>
-            <a:pPr>
-              <a:spcAft>
-                <a:spcPts val="1200"/>
-              </a:spcAft>
-            </a:pPr>
-            <a:r>
-              <a:rPr sz="2200" b="0">
-                <a:solidFill>
-                  <a:srgbClr val="10243A"/>
-                </a:solidFill>
-                <a:latin typeface="Arial"/>
-              </a:rPr>
-              <a:t>Downgrade guard and server/channel/input-error checks captured in logs.</a:t>
-            </a:r>
-          </a:p>
-        </p:txBody>
-      </p:sp>
-      <p:sp>
-        <p:nvSpPr>
-          <p:cNvPr id="17" name="TextBox 16"/>
-          <p:cNvSpPr txBox="1"/>
-          <p:nvPr/>
-        </p:nvSpPr>
-        <p:spPr>
-          <a:xfrm>
-            <a:off x="594360" y="5166360"/>
-            <a:ext cx="274320" cy="457200"/>
-          </a:xfrm>
-          <a:prstGeom prst="rect">
-            <a:avLst/>
-          </a:prstGeom>
-          <a:noFill/>
-        </p:spPr>
-        <p:txBody>
-          <a:bodyPr wrap="square" lIns="73152" rIns="73152" tIns="36576" bIns="36576">
-            <a:spAutoFit/>
-          </a:bodyPr>
-          <a:lstStyle/>
-          <a:p>
-            <a:pPr>
-              <a:spcAft>
-                <a:spcPts val="1200"/>
-              </a:spcAft>
-            </a:pPr>
-            <a:r>
-              <a:rPr sz="2200" b="1">
-                <a:solidFill>
-                  <a:srgbClr val="075985"/>
-                </a:solidFill>
-                <a:latin typeface="Arial"/>
-              </a:rPr>
-              <a:t>-</a:t>
-            </a:r>
-          </a:p>
-        </p:txBody>
-      </p:sp>
-      <p:sp>
-        <p:nvSpPr>
-          <p:cNvPr id="18" name="TextBox 17"/>
-          <p:cNvSpPr txBox="1"/>
-          <p:nvPr/>
-        </p:nvSpPr>
-        <p:spPr>
-          <a:xfrm>
-            <a:off x="914400" y="5166360"/>
-            <a:ext cx="10607040" cy="603503"/>
-          </a:xfrm>
-          <a:prstGeom prst="rect">
-            <a:avLst/>
-          </a:prstGeom>
-          <a:noFill/>
-        </p:spPr>
-        <p:txBody>
-          <a:bodyPr wrap="square" lIns="73152" rIns="73152" tIns="36576" bIns="36576">
-            <a:spAutoFit/>
-          </a:bodyPr>
-          <a:lstStyle/>
-          <a:p>
-            <a:pPr>
-              <a:spcAft>
-                <a:spcPts val="1200"/>
-              </a:spcAft>
-            </a:pPr>
-            <a:r>
-              <a:rPr sz="2200" b="0">
-                <a:solidFill>
-                  <a:srgbClr val="10243A"/>
-                </a:solidFill>
-                <a:latin typeface="Arial"/>
-              </a:rPr>
-              <a:t>Limitation: Wi-Fi loss during transfer remains inconclusive.</a:t>
+              <a:t>Open limitation: Wi-Fi loss during an active transfer remains inconclusive.</a:t>
             </a:r>
           </a:p>
         </p:txBody>
@@ -8617,52 +9203,575 @@
       </p:sp>
       <p:sp>
         <p:nvSpPr>
-          <p:cNvPr id="7" name="TextBox 6"/>
-          <p:cNvSpPr txBox="1"/>
+          <p:cNvPr id="7" name="Rounded Rectangle 6"/>
+          <p:cNvSpPr/>
           <p:nvPr/>
         </p:nvSpPr>
         <p:spPr>
           <a:xfrm>
             <a:off x="594360" y="1691640"/>
-            <a:ext cx="10972800" cy="548640"/>
-          </a:xfrm>
-          <a:prstGeom prst="rect">
-            <a:avLst/>
-          </a:prstGeom>
-          <a:noFill/>
-        </p:spPr>
-        <p:txBody>
-          <a:bodyPr wrap="square" lIns="73152" rIns="73152" tIns="36576" bIns="36576">
-            <a:spAutoFit/>
-          </a:bodyPr>
-          <a:lstStyle/>
-          <a:p>
-            <a:pPr>
-              <a:spcAft>
-                <a:spcPts val="1200"/>
-              </a:spcAft>
-            </a:pPr>
-            <a:r>
-              <a:rPr sz="2600" b="1">
+            <a:ext cx="2468880" cy="960120"/>
+          </a:xfrm>
+          <a:prstGeom prst="roundRect">
+            <a:avLst/>
+          </a:prstGeom>
+          <a:solidFill>
+            <a:srgbClr val="E8F1F7"/>
+          </a:solidFill>
+          <a:ln>
+            <a:noFill/>
+          </a:ln>
+        </p:spPr>
+        <p:style>
+          <a:lnRef idx="1">
+            <a:schemeClr val="accent1"/>
+          </a:lnRef>
+          <a:fillRef idx="3">
+            <a:schemeClr val="accent1"/>
+          </a:fillRef>
+          <a:effectRef idx="2">
+            <a:schemeClr val="accent1"/>
+          </a:effectRef>
+          <a:fontRef idx="minor">
+            <a:schemeClr val="lt1"/>
+          </a:fontRef>
+        </p:style>
+        <p:txBody>
+          <a:bodyPr rtlCol="0" anchor="ctr"/>
+          <a:lstStyle/>
+          <a:p>
+            <a:pPr algn="ctr"/>
+          </a:p>
+        </p:txBody>
+      </p:sp>
+      <p:sp>
+        <p:nvSpPr>
+          <p:cNvPr id="8" name="TextBox 7"/>
+          <p:cNvSpPr txBox="1"/>
+          <p:nvPr/>
+        </p:nvSpPr>
+        <p:spPr>
+          <a:xfrm>
+            <a:off x="704088" y="1773936"/>
+            <a:ext cx="731520" cy="594360"/>
+          </a:xfrm>
+          <a:prstGeom prst="rect">
+            <a:avLst/>
+          </a:prstGeom>
+          <a:noFill/>
+        </p:spPr>
+        <p:txBody>
+          <a:bodyPr wrap="square" lIns="73152" rIns="73152" tIns="36576" bIns="36576">
+            <a:spAutoFit/>
+          </a:bodyPr>
+          <a:lstStyle/>
+          <a:p>
+            <a:pPr>
+              <a:spcAft>
+                <a:spcPts val="1200"/>
+              </a:spcAft>
+            </a:pPr>
+            <a:r>
+              <a:rPr sz="3200" b="1">
+                <a:solidFill>
+                  <a:srgbClr val="075985"/>
+                </a:solidFill>
+                <a:latin typeface="Arial"/>
+              </a:rPr>
+              <a:t>4</a:t>
+            </a:r>
+          </a:p>
+        </p:txBody>
+      </p:sp>
+      <p:sp>
+        <p:nvSpPr>
+          <p:cNvPr id="9" name="TextBox 8"/>
+          <p:cNvSpPr txBox="1"/>
+          <p:nvPr/>
+        </p:nvSpPr>
+        <p:spPr>
+          <a:xfrm>
+            <a:off x="1463040" y="1938528"/>
+            <a:ext cx="1508760" cy="411480"/>
+          </a:xfrm>
+          <a:prstGeom prst="rect">
+            <a:avLst/>
+          </a:prstGeom>
+          <a:noFill/>
+        </p:spPr>
+        <p:txBody>
+          <a:bodyPr wrap="square" lIns="73152" rIns="73152" tIns="36576" bIns="36576">
+            <a:spAutoFit/>
+          </a:bodyPr>
+          <a:lstStyle/>
+          <a:p>
+            <a:pPr>
+              <a:spcAft>
+                <a:spcPts val="1200"/>
+              </a:spcAft>
+            </a:pPr>
+            <a:r>
+              <a:rPr sz="1800" b="1">
+                <a:solidFill>
+                  <a:srgbClr val="075985"/>
+                </a:solidFill>
+                <a:latin typeface="Arial"/>
+              </a:rPr>
+              <a:t>LIVE TESTS</a:t>
+            </a:r>
+          </a:p>
+        </p:txBody>
+      </p:sp>
+      <p:sp>
+        <p:nvSpPr>
+          <p:cNvPr id="10" name="Rounded Rectangle 9"/>
+          <p:cNvSpPr/>
+          <p:nvPr/>
+        </p:nvSpPr>
+        <p:spPr>
+          <a:xfrm>
+            <a:off x="3429000" y="1691640"/>
+            <a:ext cx="2468880" cy="960120"/>
+          </a:xfrm>
+          <a:prstGeom prst="roundRect">
+            <a:avLst/>
+          </a:prstGeom>
+          <a:solidFill>
+            <a:srgbClr val="E8F1F7"/>
+          </a:solidFill>
+          <a:ln>
+            <a:noFill/>
+          </a:ln>
+        </p:spPr>
+        <p:style>
+          <a:lnRef idx="1">
+            <a:schemeClr val="accent1"/>
+          </a:lnRef>
+          <a:fillRef idx="3">
+            <a:schemeClr val="accent1"/>
+          </a:fillRef>
+          <a:effectRef idx="2">
+            <a:schemeClr val="accent1"/>
+          </a:effectRef>
+          <a:fontRef idx="minor">
+            <a:schemeClr val="lt1"/>
+          </a:fontRef>
+        </p:style>
+        <p:txBody>
+          <a:bodyPr rtlCol="0" anchor="ctr"/>
+          <a:lstStyle/>
+          <a:p>
+            <a:pPr algn="ctr"/>
+          </a:p>
+        </p:txBody>
+      </p:sp>
+      <p:sp>
+        <p:nvSpPr>
+          <p:cNvPr id="11" name="TextBox 10"/>
+          <p:cNvSpPr txBox="1"/>
+          <p:nvPr/>
+        </p:nvSpPr>
+        <p:spPr>
+          <a:xfrm>
+            <a:off x="3538728" y="1773936"/>
+            <a:ext cx="731520" cy="594360"/>
+          </a:xfrm>
+          <a:prstGeom prst="rect">
+            <a:avLst/>
+          </a:prstGeom>
+          <a:noFill/>
+        </p:spPr>
+        <p:txBody>
+          <a:bodyPr wrap="square" lIns="73152" rIns="73152" tIns="36576" bIns="36576">
+            <a:spAutoFit/>
+          </a:bodyPr>
+          <a:lstStyle/>
+          <a:p>
+            <a:pPr>
+              <a:spcAft>
+                <a:spcPts val="1200"/>
+              </a:spcAft>
+            </a:pPr>
+            <a:r>
+              <a:rPr sz="3200" b="1">
+                <a:solidFill>
+                  <a:srgbClr val="166534"/>
+                </a:solidFill>
+                <a:latin typeface="Arial"/>
+              </a:rPr>
+              <a:t>1</a:t>
+            </a:r>
+          </a:p>
+        </p:txBody>
+      </p:sp>
+      <p:sp>
+        <p:nvSpPr>
+          <p:cNvPr id="12" name="TextBox 11"/>
+          <p:cNvSpPr txBox="1"/>
+          <p:nvPr/>
+        </p:nvSpPr>
+        <p:spPr>
+          <a:xfrm>
+            <a:off x="4297680" y="1938528"/>
+            <a:ext cx="1508760" cy="411480"/>
+          </a:xfrm>
+          <a:prstGeom prst="rect">
+            <a:avLst/>
+          </a:prstGeom>
+          <a:noFill/>
+        </p:spPr>
+        <p:txBody>
+          <a:bodyPr wrap="square" lIns="73152" rIns="73152" tIns="36576" bIns="36576">
+            <a:spAutoFit/>
+          </a:bodyPr>
+          <a:lstStyle/>
+          <a:p>
+            <a:pPr>
+              <a:spcAft>
+                <a:spcPts val="1200"/>
+              </a:spcAft>
+            </a:pPr>
+            <a:r>
+              <a:rPr sz="1800" b="1">
+                <a:solidFill>
+                  <a:srgbClr val="166534"/>
+                </a:solidFill>
+                <a:latin typeface="Arial"/>
+              </a:rPr>
+              <a:t>PASS</a:t>
+            </a:r>
+          </a:p>
+        </p:txBody>
+      </p:sp>
+      <p:sp>
+        <p:nvSpPr>
+          <p:cNvPr id="13" name="Rounded Rectangle 12"/>
+          <p:cNvSpPr/>
+          <p:nvPr/>
+        </p:nvSpPr>
+        <p:spPr>
+          <a:xfrm>
+            <a:off x="6263640" y="1691640"/>
+            <a:ext cx="2468880" cy="960120"/>
+          </a:xfrm>
+          <a:prstGeom prst="roundRect">
+            <a:avLst/>
+          </a:prstGeom>
+          <a:solidFill>
+            <a:srgbClr val="E8F1F7"/>
+          </a:solidFill>
+          <a:ln>
+            <a:noFill/>
+          </a:ln>
+        </p:spPr>
+        <p:style>
+          <a:lnRef idx="1">
+            <a:schemeClr val="accent1"/>
+          </a:lnRef>
+          <a:fillRef idx="3">
+            <a:schemeClr val="accent1"/>
+          </a:fillRef>
+          <a:effectRef idx="2">
+            <a:schemeClr val="accent1"/>
+          </a:effectRef>
+          <a:fontRef idx="minor">
+            <a:schemeClr val="lt1"/>
+          </a:fontRef>
+        </p:style>
+        <p:txBody>
+          <a:bodyPr rtlCol="0" anchor="ctr"/>
+          <a:lstStyle/>
+          <a:p>
+            <a:pPr algn="ctr"/>
+          </a:p>
+        </p:txBody>
+      </p:sp>
+      <p:sp>
+        <p:nvSpPr>
+          <p:cNvPr id="14" name="TextBox 13"/>
+          <p:cNvSpPr txBox="1"/>
+          <p:nvPr/>
+        </p:nvSpPr>
+        <p:spPr>
+          <a:xfrm>
+            <a:off x="6373368" y="1773936"/>
+            <a:ext cx="731520" cy="594360"/>
+          </a:xfrm>
+          <a:prstGeom prst="rect">
+            <a:avLst/>
+          </a:prstGeom>
+          <a:noFill/>
+        </p:spPr>
+        <p:txBody>
+          <a:bodyPr wrap="square" lIns="73152" rIns="73152" tIns="36576" bIns="36576">
+            <a:spAutoFit/>
+          </a:bodyPr>
+          <a:lstStyle/>
+          <a:p>
+            <a:pPr>
+              <a:spcAft>
+                <a:spcPts val="1200"/>
+              </a:spcAft>
+            </a:pPr>
+            <a:r>
+              <a:rPr sz="3200" b="1">
+                <a:solidFill>
+                  <a:srgbClr val="991B1B"/>
+                </a:solidFill>
+                <a:latin typeface="Arial"/>
+              </a:rPr>
+              <a:t>3</a:t>
+            </a:r>
+          </a:p>
+        </p:txBody>
+      </p:sp>
+      <p:sp>
+        <p:nvSpPr>
+          <p:cNvPr id="15" name="TextBox 14"/>
+          <p:cNvSpPr txBox="1"/>
+          <p:nvPr/>
+        </p:nvSpPr>
+        <p:spPr>
+          <a:xfrm>
+            <a:off x="7132320" y="1938528"/>
+            <a:ext cx="1508760" cy="411480"/>
+          </a:xfrm>
+          <a:prstGeom prst="rect">
+            <a:avLst/>
+          </a:prstGeom>
+          <a:noFill/>
+        </p:spPr>
+        <p:txBody>
+          <a:bodyPr wrap="square" lIns="73152" rIns="73152" tIns="36576" bIns="36576">
+            <a:spAutoFit/>
+          </a:bodyPr>
+          <a:lstStyle/>
+          <a:p>
+            <a:pPr>
+              <a:spcAft>
+                <a:spcPts val="1200"/>
+              </a:spcAft>
+            </a:pPr>
+            <a:r>
+              <a:rPr sz="1800" b="1">
+                <a:solidFill>
+                  <a:srgbClr val="991B1B"/>
+                </a:solidFill>
+                <a:latin typeface="Arial"/>
+              </a:rPr>
+              <a:t>FAIL</a:t>
+            </a:r>
+          </a:p>
+        </p:txBody>
+      </p:sp>
+      <p:sp>
+        <p:nvSpPr>
+          <p:cNvPr id="16" name="Rounded Rectangle 15"/>
+          <p:cNvSpPr/>
+          <p:nvPr/>
+        </p:nvSpPr>
+        <p:spPr>
+          <a:xfrm>
+            <a:off x="9098280" y="1691640"/>
+            <a:ext cx="2468880" cy="960120"/>
+          </a:xfrm>
+          <a:prstGeom prst="roundRect">
+            <a:avLst/>
+          </a:prstGeom>
+          <a:solidFill>
+            <a:srgbClr val="E8F1F7"/>
+          </a:solidFill>
+          <a:ln>
+            <a:noFill/>
+          </a:ln>
+        </p:spPr>
+        <p:style>
+          <a:lnRef idx="1">
+            <a:schemeClr val="accent1"/>
+          </a:lnRef>
+          <a:fillRef idx="3">
+            <a:schemeClr val="accent1"/>
+          </a:fillRef>
+          <a:effectRef idx="2">
+            <a:schemeClr val="accent1"/>
+          </a:effectRef>
+          <a:fontRef idx="minor">
+            <a:schemeClr val="lt1"/>
+          </a:fontRef>
+        </p:style>
+        <p:txBody>
+          <a:bodyPr rtlCol="0" anchor="ctr"/>
+          <a:lstStyle/>
+          <a:p>
+            <a:pPr algn="ctr"/>
+          </a:p>
+        </p:txBody>
+      </p:sp>
+      <p:sp>
+        <p:nvSpPr>
+          <p:cNvPr id="17" name="TextBox 16"/>
+          <p:cNvSpPr txBox="1"/>
+          <p:nvPr/>
+        </p:nvSpPr>
+        <p:spPr>
+          <a:xfrm>
+            <a:off x="9208007" y="1773936"/>
+            <a:ext cx="731520" cy="594360"/>
+          </a:xfrm>
+          <a:prstGeom prst="rect">
+            <a:avLst/>
+          </a:prstGeom>
+          <a:noFill/>
+        </p:spPr>
+        <p:txBody>
+          <a:bodyPr wrap="square" lIns="73152" rIns="73152" tIns="36576" bIns="36576">
+            <a:spAutoFit/>
+          </a:bodyPr>
+          <a:lstStyle/>
+          <a:p>
+            <a:pPr>
+              <a:spcAft>
+                <a:spcPts val="1200"/>
+              </a:spcAft>
+            </a:pPr>
+            <a:r>
+              <a:rPr sz="3200" b="1">
+                <a:solidFill>
+                  <a:srgbClr val="075985"/>
+                </a:solidFill>
+                <a:latin typeface="Arial"/>
+              </a:rPr>
+              <a:t>0</a:t>
+            </a:r>
+          </a:p>
+        </p:txBody>
+      </p:sp>
+      <p:sp>
+        <p:nvSpPr>
+          <p:cNvPr id="18" name="TextBox 17"/>
+          <p:cNvSpPr txBox="1"/>
+          <p:nvPr/>
+        </p:nvSpPr>
+        <p:spPr>
+          <a:xfrm>
+            <a:off x="9966959" y="1938528"/>
+            <a:ext cx="1508760" cy="411480"/>
+          </a:xfrm>
+          <a:prstGeom prst="rect">
+            <a:avLst/>
+          </a:prstGeom>
+          <a:noFill/>
+        </p:spPr>
+        <p:txBody>
+          <a:bodyPr wrap="square" lIns="73152" rIns="73152" tIns="36576" bIns="36576">
+            <a:spAutoFit/>
+          </a:bodyPr>
+          <a:lstStyle/>
+          <a:p>
+            <a:pPr>
+              <a:spcAft>
+                <a:spcPts val="1200"/>
+              </a:spcAft>
+            </a:pPr>
+            <a:r>
+              <a:rPr sz="1800" b="1">
+                <a:solidFill>
+                  <a:srgbClr val="075985"/>
+                </a:solidFill>
+                <a:latin typeface="Arial"/>
+              </a:rPr>
+              <a:t>ERRORS</a:t>
+            </a:r>
+          </a:p>
+        </p:txBody>
+      </p:sp>
+      <p:sp>
+        <p:nvSpPr>
+          <p:cNvPr id="19" name="TextBox 18"/>
+          <p:cNvSpPr txBox="1"/>
+          <p:nvPr/>
+        </p:nvSpPr>
+        <p:spPr>
+          <a:xfrm>
+            <a:off x="594360" y="2852928"/>
+            <a:ext cx="1005840" cy="411480"/>
+          </a:xfrm>
+          <a:prstGeom prst="rect">
+            <a:avLst/>
+          </a:prstGeom>
+          <a:noFill/>
+        </p:spPr>
+        <p:txBody>
+          <a:bodyPr wrap="square" lIns="73152" rIns="73152" tIns="36576" bIns="36576">
+            <a:spAutoFit/>
+          </a:bodyPr>
+          <a:lstStyle/>
+          <a:p>
+            <a:pPr>
+              <a:spcAft>
+                <a:spcPts val="1200"/>
+              </a:spcAft>
+            </a:pPr>
+            <a:r>
+              <a:rPr sz="2200" b="1">
+                <a:solidFill>
+                  <a:srgbClr val="991B1B"/>
+                </a:solidFill>
+                <a:latin typeface="Arial"/>
+              </a:rPr>
+              <a:t>FAIL</a:t>
+            </a:r>
+          </a:p>
+        </p:txBody>
+      </p:sp>
+      <p:sp>
+        <p:nvSpPr>
+          <p:cNvPr id="20" name="TextBox 19"/>
+          <p:cNvSpPr txBox="1"/>
+          <p:nvPr/>
+        </p:nvSpPr>
+        <p:spPr>
+          <a:xfrm>
+            <a:off x="1691640" y="2852928"/>
+            <a:ext cx="9784080" cy="457200"/>
+          </a:xfrm>
+          <a:prstGeom prst="rect">
+            <a:avLst/>
+          </a:prstGeom>
+          <a:noFill/>
+        </p:spPr>
+        <p:txBody>
+          <a:bodyPr wrap="square" lIns="73152" rIns="73152" tIns="36576" bIns="36576">
+            <a:spAutoFit/>
+          </a:bodyPr>
+          <a:lstStyle/>
+          <a:p>
+            <a:pPr>
+              <a:spcAft>
+                <a:spcPts val="1200"/>
+              </a:spcAft>
+            </a:pPr>
+            <a:r>
+              <a:rPr sz="2200" b="0">
                 <a:solidFill>
                   <a:srgbClr val="10243A"/>
                 </a:solidFill>
                 <a:latin typeface="Arial"/>
               </a:rPr>
-              <a:t>Firmware 2.3.0: 4 tests | 1 PASS | 3 FAIL | 0 errors</a:t>
-            </a:r>
-          </a:p>
-        </p:txBody>
-      </p:sp>
-      <p:sp>
-        <p:nvSpPr>
-          <p:cNvPr id="8" name="TextBox 7"/>
-          <p:cNvSpPr txBox="1"/>
-          <p:nvPr/>
-        </p:nvSpPr>
-        <p:spPr>
-          <a:xfrm>
-            <a:off x="594360" y="2423160"/>
+              <a:t>BUG-01: distance 20 must be accepted.</a:t>
+            </a:r>
+          </a:p>
+        </p:txBody>
+      </p:sp>
+      <p:sp>
+        <p:nvSpPr>
+          <p:cNvPr id="21" name="TextBox 20"/>
+          <p:cNvSpPr txBox="1"/>
+          <p:nvPr/>
+        </p:nvSpPr>
+        <p:spPr>
+          <a:xfrm>
+            <a:off x="594360" y="3300984"/>
             <a:ext cx="1005840" cy="411480"/>
           </a:xfrm>
           <a:prstGeom prst="rect">
@@ -8695,13 +9804,13 @@
       </p:sp>
       <p:sp>
         <p:nvSpPr>
-          <p:cNvPr id="9" name="TextBox 8"/>
-          <p:cNvSpPr txBox="1"/>
-          <p:nvPr/>
-        </p:nvSpPr>
-        <p:spPr>
-          <a:xfrm>
-            <a:off x="1691640" y="2423160"/>
+          <p:cNvPr id="22" name="TextBox 21"/>
+          <p:cNvSpPr txBox="1"/>
+          <p:nvPr/>
+        </p:nvSpPr>
+        <p:spPr>
+          <a:xfrm>
+            <a:off x="1691640" y="3300984"/>
             <a:ext cx="9784080" cy="457200"/>
           </a:xfrm>
           <a:prstGeom prst="rect">
@@ -8727,20 +9836,20 @@
                 </a:solidFill>
                 <a:latin typeface="Arial"/>
               </a:rPr>
-              <a:t>BUG-01: distance 20 must be accepted.</a:t>
-            </a:r>
-          </a:p>
-        </p:txBody>
-      </p:sp>
-      <p:sp>
-        <p:nvSpPr>
-          <p:cNvPr id="10" name="TextBox 9"/>
-          <p:cNvSpPr txBox="1"/>
-          <p:nvPr/>
-        </p:nvSpPr>
-        <p:spPr>
-          <a:xfrm>
-            <a:off x="594360" y="2944368"/>
+              <a:t>BUG-02: relay pulse 99 ms must be rejected.</a:t>
+            </a:r>
+          </a:p>
+        </p:txBody>
+      </p:sp>
+      <p:sp>
+        <p:nvSpPr>
+          <p:cNvPr id="23" name="TextBox 22"/>
+          <p:cNvSpPr txBox="1"/>
+          <p:nvPr/>
+        </p:nvSpPr>
+        <p:spPr>
+          <a:xfrm>
+            <a:off x="594360" y="3749039"/>
             <a:ext cx="1005840" cy="411480"/>
           </a:xfrm>
           <a:prstGeom prst="rect">
@@ -8762,6 +9871,84 @@
             <a:r>
               <a:rPr sz="2200" b="1">
                 <a:solidFill>
+                  <a:srgbClr val="166534"/>
+                </a:solidFill>
+                <a:latin typeface="Arial"/>
+              </a:rPr>
+              <a:t>PASS</a:t>
+            </a:r>
+          </a:p>
+        </p:txBody>
+      </p:sp>
+      <p:sp>
+        <p:nvSpPr>
+          <p:cNvPr id="24" name="TextBox 23"/>
+          <p:cNvSpPr txBox="1"/>
+          <p:nvPr/>
+        </p:nvSpPr>
+        <p:spPr>
+          <a:xfrm>
+            <a:off x="1691640" y="3749039"/>
+            <a:ext cx="9784080" cy="457200"/>
+          </a:xfrm>
+          <a:prstGeom prst="rect">
+            <a:avLst/>
+          </a:prstGeom>
+          <a:noFill/>
+        </p:spPr>
+        <p:txBody>
+          <a:bodyPr wrap="square" lIns="73152" rIns="73152" tIns="36576" bIns="36576">
+            <a:spAutoFit/>
+          </a:bodyPr>
+          <a:lstStyle/>
+          <a:p>
+            <a:pPr>
+              <a:spcAft>
+                <a:spcPts val="1200"/>
+              </a:spcAft>
+            </a:pPr>
+            <a:r>
+              <a:rPr sz="2200" b="0">
+                <a:solidFill>
+                  <a:srgbClr val="10243A"/>
+                </a:solidFill>
+                <a:latin typeface="Arial"/>
+              </a:rPr>
+              <a:t>BUG-03: health 300 s accepted; 301 s rejected.</a:t>
+            </a:r>
+          </a:p>
+        </p:txBody>
+      </p:sp>
+      <p:sp>
+        <p:nvSpPr>
+          <p:cNvPr id="25" name="TextBox 24"/>
+          <p:cNvSpPr txBox="1"/>
+          <p:nvPr/>
+        </p:nvSpPr>
+        <p:spPr>
+          <a:xfrm>
+            <a:off x="594360" y="4197096"/>
+            <a:ext cx="1005840" cy="411480"/>
+          </a:xfrm>
+          <a:prstGeom prst="rect">
+            <a:avLst/>
+          </a:prstGeom>
+          <a:noFill/>
+        </p:spPr>
+        <p:txBody>
+          <a:bodyPr wrap="square" lIns="73152" rIns="73152" tIns="36576" bIns="36576">
+            <a:spAutoFit/>
+          </a:bodyPr>
+          <a:lstStyle/>
+          <a:p>
+            <a:pPr>
+              <a:spcAft>
+                <a:spcPts val="1200"/>
+              </a:spcAft>
+            </a:pPr>
+            <a:r>
+              <a:rPr sz="2200" b="1">
+                <a:solidFill>
                   <a:srgbClr val="991B1B"/>
                 </a:solidFill>
                 <a:latin typeface="Arial"/>
@@ -8773,13 +9960,13 @@
       </p:sp>
       <p:sp>
         <p:nvSpPr>
-          <p:cNvPr id="11" name="TextBox 10"/>
-          <p:cNvSpPr txBox="1"/>
-          <p:nvPr/>
-        </p:nvSpPr>
-        <p:spPr>
-          <a:xfrm>
-            <a:off x="1691640" y="2944368"/>
+          <p:cNvPr id="26" name="TextBox 25"/>
+          <p:cNvSpPr txBox="1"/>
+          <p:nvPr/>
+        </p:nvSpPr>
+        <p:spPr>
+          <a:xfrm>
+            <a:off x="1691640" y="4197096"/>
             <a:ext cx="9784080" cy="457200"/>
           </a:xfrm>
           <a:prstGeom prst="rect">
@@ -8805,162 +9992,6 @@
                 </a:solidFill>
                 <a:latin typeface="Arial"/>
               </a:rPr>
-              <a:t>BUG-02: relay pulse 99 ms must be rejected.</a:t>
-            </a:r>
-          </a:p>
-        </p:txBody>
-      </p:sp>
-      <p:sp>
-        <p:nvSpPr>
-          <p:cNvPr id="12" name="TextBox 11"/>
-          <p:cNvSpPr txBox="1"/>
-          <p:nvPr/>
-        </p:nvSpPr>
-        <p:spPr>
-          <a:xfrm>
-            <a:off x="594360" y="3465576"/>
-            <a:ext cx="1005840" cy="411480"/>
-          </a:xfrm>
-          <a:prstGeom prst="rect">
-            <a:avLst/>
-          </a:prstGeom>
-          <a:noFill/>
-        </p:spPr>
-        <p:txBody>
-          <a:bodyPr wrap="square" lIns="73152" rIns="73152" tIns="36576" bIns="36576">
-            <a:spAutoFit/>
-          </a:bodyPr>
-          <a:lstStyle/>
-          <a:p>
-            <a:pPr>
-              <a:spcAft>
-                <a:spcPts val="1200"/>
-              </a:spcAft>
-            </a:pPr>
-            <a:r>
-              <a:rPr sz="2200" b="1">
-                <a:solidFill>
-                  <a:srgbClr val="075985"/>
-                </a:solidFill>
-                <a:latin typeface="Arial"/>
-              </a:rPr>
-              <a:t>PASS</a:t>
-            </a:r>
-          </a:p>
-        </p:txBody>
-      </p:sp>
-      <p:sp>
-        <p:nvSpPr>
-          <p:cNvPr id="13" name="TextBox 12"/>
-          <p:cNvSpPr txBox="1"/>
-          <p:nvPr/>
-        </p:nvSpPr>
-        <p:spPr>
-          <a:xfrm>
-            <a:off x="1691640" y="3465576"/>
-            <a:ext cx="9784080" cy="457200"/>
-          </a:xfrm>
-          <a:prstGeom prst="rect">
-            <a:avLst/>
-          </a:prstGeom>
-          <a:noFill/>
-        </p:spPr>
-        <p:txBody>
-          <a:bodyPr wrap="square" lIns="73152" rIns="73152" tIns="36576" bIns="36576">
-            <a:spAutoFit/>
-          </a:bodyPr>
-          <a:lstStyle/>
-          <a:p>
-            <a:pPr>
-              <a:spcAft>
-                <a:spcPts val="1200"/>
-              </a:spcAft>
-            </a:pPr>
-            <a:r>
-              <a:rPr sz="2200" b="0">
-                <a:solidFill>
-                  <a:srgbClr val="10243A"/>
-                </a:solidFill>
-                <a:latin typeface="Arial"/>
-              </a:rPr>
-              <a:t>BUG-03: health 300 s accepted; 301 s rejected.</a:t>
-            </a:r>
-          </a:p>
-        </p:txBody>
-      </p:sp>
-      <p:sp>
-        <p:nvSpPr>
-          <p:cNvPr id="14" name="TextBox 13"/>
-          <p:cNvSpPr txBox="1"/>
-          <p:nvPr/>
-        </p:nvSpPr>
-        <p:spPr>
-          <a:xfrm>
-            <a:off x="594360" y="3986783"/>
-            <a:ext cx="1005840" cy="411480"/>
-          </a:xfrm>
-          <a:prstGeom prst="rect">
-            <a:avLst/>
-          </a:prstGeom>
-          <a:noFill/>
-        </p:spPr>
-        <p:txBody>
-          <a:bodyPr wrap="square" lIns="73152" rIns="73152" tIns="36576" bIns="36576">
-            <a:spAutoFit/>
-          </a:bodyPr>
-          <a:lstStyle/>
-          <a:p>
-            <a:pPr>
-              <a:spcAft>
-                <a:spcPts val="1200"/>
-              </a:spcAft>
-            </a:pPr>
-            <a:r>
-              <a:rPr sz="2200" b="1">
-                <a:solidFill>
-                  <a:srgbClr val="991B1B"/>
-                </a:solidFill>
-                <a:latin typeface="Arial"/>
-              </a:rPr>
-              <a:t>FAIL</a:t>
-            </a:r>
-          </a:p>
-        </p:txBody>
-      </p:sp>
-      <p:sp>
-        <p:nvSpPr>
-          <p:cNvPr id="15" name="TextBox 14"/>
-          <p:cNvSpPr txBox="1"/>
-          <p:nvPr/>
-        </p:nvSpPr>
-        <p:spPr>
-          <a:xfrm>
-            <a:off x="1691640" y="3986783"/>
-            <a:ext cx="9784080" cy="457200"/>
-          </a:xfrm>
-          <a:prstGeom prst="rect">
-            <a:avLst/>
-          </a:prstGeom>
-          <a:noFill/>
-        </p:spPr>
-        <p:txBody>
-          <a:bodyPr wrap="square" lIns="73152" rIns="73152" tIns="36576" bIns="36576">
-            <a:spAutoFit/>
-          </a:bodyPr>
-          <a:lstStyle/>
-          <a:p>
-            <a:pPr>
-              <a:spcAft>
-                <a:spcPts val="1200"/>
-              </a:spcAft>
-            </a:pPr>
-            <a:r>
-              <a:rPr sz="2200" b="0">
-                <a:solidFill>
-                  <a:srgbClr val="10243A"/>
-                </a:solidFill>
-                <a:latin typeface="Arial"/>
-              </a:rPr>
               <a:t>BUG-07: distance calibrate reset must work.</a:t>
             </a:r>
           </a:p>
@@ -8968,7 +9999,7 @@
       </p:sp>
       <p:sp>
         <p:nvSpPr>
-          <p:cNvPr id="16" name="TextBox 15"/>
+          <p:cNvPr id="27" name="TextBox 26"/>
           <p:cNvSpPr txBox="1"/>
           <p:nvPr/>
         </p:nvSpPr>
@@ -9023,7 +10054,7 @@
       </p:sp>
       <p:sp>
         <p:nvSpPr>
-          <p:cNvPr id="17" name="TextBox 16"/>
+          <p:cNvPr id="28" name="TextBox 27"/>
           <p:cNvSpPr txBox="1"/>
           <p:nvPr/>
         </p:nvSpPr>

</xml_diff>